<commit_message>
Cada passo do pipeline vira um slide proprio, nos dois decks
A demonstracao deixa de ser um slide so, com a coisa inteira espremida
dentro, e vira sete slides, um por tela: microarea, selecao, rota
candidata, a reprovacao, a outra rota, a aprovacao e o roteiro final. Os
dois decks sobem de 14 para 20 slides e seguem identicos entre si.

Cada slide traz o mapa daquele passo em tamanho grande a esquerda e a
explicacao a direita, com selo de reprovada ou valida, os numeros do passo
e um remate. Os mapas foram recapturados ao dobro da resolucao, porque
agora ocupam meio slide e nao um sexto dele.

O slide que mais ganha com a separacao e o da segunda rota candidata: ela
custa exatamente os mesmos 94 minutos da rota reprovada, por ser a mesma
volta ao contrario, e agora isso tem um slide inteiro para ser dito.

Co-Authored-By: Claude Opus 5 (1M context) <noreply@anthropic.com>
</commit_message>
<xml_diff>
--- a/apresentacao/3/apresentacao-final.pptx
+++ b/apresentacao/3/apresentacao-final.pptx
@@ -19,9 +19,15 @@
     <p:sldId id="267" r:id="rId13"/>
     <p:sldId id="268" r:id="rId14"/>
     <p:sldId id="269" r:id="rId15"/>
+    <p:sldId id="270" r:id="rId16"/>
+    <p:sldId id="271" r:id="rId17"/>
+    <p:sldId id="272" r:id="rId18"/>
+    <p:sldId id="273" r:id="rId19"/>
+    <p:sldId id="274" r:id="rId20"/>
+    <p:sldId id="275" r:id="rId21"/>
   </p:sldIdLst>
   <p:notesMasterIdLst>
-    <p:notesMasterId r:id="rId16"/>
+    <p:notesMasterId r:id="rId22"/>
   </p:notesMasterIdLst>
   <p:sldSz cx="12192000" cy="6858000"/>
   <p:notesSz cx="6858000" cy="12192000"/>
@@ -867,7 +873,7 @@
           <a:p>
             <a:r>
               <a:rPr lang="en-US" dirty="0"/>
-              <a:t>No HTML esta demonstracao roda VIVA dentro do slide. Aqui ela esta como storyboard, e o link abre a versao viva. Navegue pelos sete passos. O ponto alto e o quarto e o quinto: as duas rotas candidatas custam os MESMOS 94 minutos de caminhada, porque sao a mesma volta percorrida em sentidos opostos, e ainda assim uma cumpre a norma e a outra nao. Em p4, de urgencia baixa, na primeira parada, enquanto p7, de urgencia alta, so viria na sexta.</a:t>
+              <a:t>Coordenadas reais de Porto Alegre, dados clinicos ficticios. Diga o recorte: um agente, um turno, uma microarea. A unidade de saude e o pino escuro marcado com U.</a:t>
             </a:r>
             <a:endParaRPr lang="en-US" dirty="0"/>
           </a:p>
@@ -955,7 +961,7 @@
           <a:p>
             <a:r>
               <a:rPr lang="en-US" dirty="0"/>
-              <a:t>Fecho. O trunfo do trabalho nao e ter usado Planning. E termos medido COMO ele ajuda neste problema, inclusive descobrindo que a resposta nao era a que esperavamos. Se a banca perguntar o que sobrou: declaratividade com efeito medido, e prova de inviabilidade. Se perguntar o que caiu: economia de tempo e exclusividade de capacidade. E a frase final: nenhuma das duas metades sozinha resolve.</a:t>
+              <a:t>Se perguntarem o criterio: prioridade clinica mais atraso relativo a janela de cada grupo, e corte no orcamento. O E5 mediu o ganho: cobertura de atrasados vai de 37% para 73%.</a:t>
             </a:r>
             <a:endParaRPr lang="en-US" dirty="0"/>
           </a:p>
@@ -979,6 +985,446 @@
             <a:fld id="{F7021451-1387-4CA6-816F-3879F97B5CBC}" type="slidenum">
               <a:rPr lang="en-US"/>
               <a:t>14</a:t>
+            </a:fld>
+            <a:endParaRPr lang="en-US"/>
+          </a:p>
+        </p:txBody>
+      </p:sp>
+    </p:spTree>
+    <p:extLst>
+      <p:ext uri="{BB962C8B-B14F-4D97-AF65-F5344CB8AC3E}">
+        <p14:creationId xmlns:p14="http://schemas.microsoft.com/office/powerpoint/2010/main" val="1024086991"/>
+      </p:ext>
+    </p:extLst>
+  </p:cSld>
+  <p:clrMapOvr>
+    <a:masterClrMapping/>
+  </p:clrMapOvr>
+</p:notes>
+</file>
+
+<file path=ppt/notesSlides/notesSlide15.xml><?xml version="1.0" encoding="utf-8"?>
+<p:notes xmlns:a="http://schemas.openxmlformats.org/drawingml/2006/main" xmlns:r="http://schemas.openxmlformats.org/officeDocument/2006/relationships" xmlns:p="http://schemas.openxmlformats.org/presentationml/2006/main">
+  <p:cSld>
+    <p:spTree>
+      <p:nvGrpSpPr>
+        <p:cNvPr id="1" name=""/>
+        <p:cNvGrpSpPr/>
+        <p:nvPr/>
+      </p:nvGrpSpPr>
+      <p:grpSpPr>
+        <a:xfrm>
+          <a:off x="0" y="0"/>
+          <a:ext cx="0" cy="0"/>
+          <a:chOff x="0" y="0"/>
+          <a:chExt cx="0" cy="0"/>
+        </a:xfrm>
+      </p:grpSpPr>
+      <p:sp>
+        <p:nvSpPr>
+          <p:cNvPr id="2" name="Slide Image Placeholder 1"/>
+          <p:cNvSpPr>
+            <a:spLocks noGrp="1" noRot="1" noChangeAspect="1"/>
+          </p:cNvSpPr>
+          <p:nvPr>
+            <p:ph type="sldImg"/>
+          </p:nvPr>
+        </p:nvSpPr>
+        <p:spPr/>
+      </p:sp>
+      <p:sp>
+        <p:nvSpPr>
+          <p:cNvPr id="3" name="Notes Placeholder 2"/>
+          <p:cNvSpPr>
+            <a:spLocks noGrp="1"/>
+          </p:cNvSpPr>
+          <p:nvPr>
+            <p:ph type="body" idx="1"/>
+          </p:nvPr>
+        </p:nvSpPr>
+        <p:spPr/>
+        <p:txBody>
+          <a:bodyPr/>
+          <a:lstStyle/>
+          <a:p>
+            <a:r>
+              <a:rPr lang="en-US" dirty="0"/>
+              <a:t>Aqui o roteirizador esta deliberadamente CEGO a norma, que e a situacao de quem usa OR-Tools ou um servico externo. O tracado segue as ruas de verdade, nao liga as coordenadas em reta.</a:t>
+            </a:r>
+            <a:endParaRPr lang="en-US" dirty="0"/>
+          </a:p>
+        </p:txBody>
+      </p:sp>
+      <p:sp>
+        <p:nvSpPr>
+          <p:cNvPr id="4" name="Slide Number Placeholder 3"/>
+          <p:cNvSpPr>
+            <a:spLocks noGrp="1"/>
+          </p:cNvSpPr>
+          <p:nvPr>
+            <p:ph type="sldNum" sz="quarter" idx="10"/>
+          </p:nvPr>
+        </p:nvSpPr>
+        <p:spPr/>
+        <p:txBody>
+          <a:bodyPr/>
+          <a:lstStyle/>
+          <a:p>
+            <a:fld id="{F7021451-1387-4CA6-816F-3879F97B5CBC}" type="slidenum">
+              <a:rPr lang="en-US"/>
+              <a:t>15</a:t>
+            </a:fld>
+            <a:endParaRPr lang="en-US"/>
+          </a:p>
+        </p:txBody>
+      </p:sp>
+    </p:spTree>
+    <p:extLst>
+      <p:ext uri="{BB962C8B-B14F-4D97-AF65-F5344CB8AC3E}">
+        <p14:creationId xmlns:p14="http://schemas.microsoft.com/office/powerpoint/2010/main" val="1024086991"/>
+      </p:ext>
+    </p:extLst>
+  </p:cSld>
+  <p:clrMapOvr>
+    <a:masterClrMapping/>
+  </p:clrMapOvr>
+</p:notes>
+</file>
+
+<file path=ppt/notesSlides/notesSlide16.xml><?xml version="1.0" encoding="utf-8"?>
+<p:notes xmlns:a="http://schemas.openxmlformats.org/drawingml/2006/main" xmlns:r="http://schemas.openxmlformats.org/officeDocument/2006/relationships" xmlns:p="http://schemas.openxmlformats.org/presentationml/2006/main">
+  <p:cSld>
+    <p:spTree>
+      <p:nvGrpSpPr>
+        <p:cNvPr id="1" name=""/>
+        <p:cNvGrpSpPr/>
+        <p:nvPr/>
+      </p:nvGrpSpPr>
+      <p:grpSpPr>
+        <a:xfrm>
+          <a:off x="0" y="0"/>
+          <a:ext cx="0" cy="0"/>
+          <a:chOff x="0" y="0"/>
+          <a:chExt cx="0" cy="0"/>
+        </a:xfrm>
+      </p:grpSpPr>
+      <p:sp>
+        <p:nvSpPr>
+          <p:cNvPr id="2" name="Slide Image Placeholder 1"/>
+          <p:cNvSpPr>
+            <a:spLocks noGrp="1" noRot="1" noChangeAspect="1"/>
+          </p:cNvSpPr>
+          <p:nvPr>
+            <p:ph type="sldImg"/>
+          </p:nvPr>
+        </p:nvSpPr>
+        <p:spPr/>
+      </p:sp>
+      <p:sp>
+        <p:nvSpPr>
+          <p:cNvPr id="3" name="Notes Placeholder 2"/>
+          <p:cNvSpPr>
+            <a:spLocks noGrp="1"/>
+          </p:cNvSpPr>
+          <p:nvPr>
+            <p:ph type="body" idx="1"/>
+          </p:nvPr>
+        </p:nvSpPr>
+        <p:spPr/>
+        <p:txBody>
+          <a:bodyPr/>
+          <a:lstStyle/>
+          <a:p>
+            <a:r>
+              <a:rPr lang="en-US" dirty="0"/>
+              <a:t>Os dois aros tracejados no mapa sao p4 e p7, os pinos 1 e 6. Este e o momento de dizer que a inviabilidade e sensivel a ordem: vale para esta rota, nao para o turno. Por isso vale voltar ao passo 2.</a:t>
+            </a:r>
+            <a:endParaRPr lang="en-US" dirty="0"/>
+          </a:p>
+        </p:txBody>
+      </p:sp>
+      <p:sp>
+        <p:nvSpPr>
+          <p:cNvPr id="4" name="Slide Number Placeholder 3"/>
+          <p:cNvSpPr>
+            <a:spLocks noGrp="1"/>
+          </p:cNvSpPr>
+          <p:nvPr>
+            <p:ph type="sldNum" sz="quarter" idx="10"/>
+          </p:nvPr>
+        </p:nvSpPr>
+        <p:spPr/>
+        <p:txBody>
+          <a:bodyPr/>
+          <a:lstStyle/>
+          <a:p>
+            <a:fld id="{F7021451-1387-4CA6-816F-3879F97B5CBC}" type="slidenum">
+              <a:rPr lang="en-US"/>
+              <a:t>16</a:t>
+            </a:fld>
+            <a:endParaRPr lang="en-US"/>
+          </a:p>
+        </p:txBody>
+      </p:sp>
+    </p:spTree>
+    <p:extLst>
+      <p:ext uri="{BB962C8B-B14F-4D97-AF65-F5344CB8AC3E}">
+        <p14:creationId xmlns:p14="http://schemas.microsoft.com/office/powerpoint/2010/main" val="1024086991"/>
+      </p:ext>
+    </p:extLst>
+  </p:cSld>
+  <p:clrMapOvr>
+    <a:masterClrMapping/>
+  </p:clrMapOvr>
+</p:notes>
+</file>
+
+<file path=ppt/notesSlides/notesSlide17.xml><?xml version="1.0" encoding="utf-8"?>
+<p:notes xmlns:a="http://schemas.openxmlformats.org/drawingml/2006/main" xmlns:r="http://schemas.openxmlformats.org/officeDocument/2006/relationships" xmlns:p="http://schemas.openxmlformats.org/presentationml/2006/main">
+  <p:cSld>
+    <p:spTree>
+      <p:nvGrpSpPr>
+        <p:cNvPr id="1" name=""/>
+        <p:cNvGrpSpPr/>
+        <p:nvPr/>
+      </p:nvGrpSpPr>
+      <p:grpSpPr>
+        <a:xfrm>
+          <a:off x="0" y="0"/>
+          <a:ext cx="0" cy="0"/>
+          <a:chOff x="0" y="0"/>
+          <a:chExt cx="0" cy="0"/>
+        </a:xfrm>
+      </p:grpSpPr>
+      <p:sp>
+        <p:nvSpPr>
+          <p:cNvPr id="2" name="Slide Image Placeholder 1"/>
+          <p:cNvSpPr>
+            <a:spLocks noGrp="1" noRot="1" noChangeAspect="1"/>
+          </p:cNvSpPr>
+          <p:nvPr>
+            <p:ph type="sldImg"/>
+          </p:nvPr>
+        </p:nvSpPr>
+        <p:spPr/>
+      </p:sp>
+      <p:sp>
+        <p:nvSpPr>
+          <p:cNvPr id="3" name="Notes Placeholder 2"/>
+          <p:cNvSpPr>
+            <a:spLocks noGrp="1"/>
+          </p:cNvSpPr>
+          <p:nvPr>
+            <p:ph type="body" idx="1"/>
+          </p:nvPr>
+        </p:nvSpPr>
+        <p:spPr/>
+        <p:txBody>
+          <a:bodyPr/>
+          <a:lstStyle/>
+          <a:p>
+            <a:r>
+              <a:rPr lang="en-US" dirty="0"/>
+              <a:t>Este e o slide que mais vale na demonstracao. Duas rotas geometricamente identicas, e so uma e executavel. O E13 mediu isso em 45 instancias: o custo da conformidade deu ZERO minuto de caminhada em todos os casos.</a:t>
+            </a:r>
+            <a:endParaRPr lang="en-US" dirty="0"/>
+          </a:p>
+        </p:txBody>
+      </p:sp>
+      <p:sp>
+        <p:nvSpPr>
+          <p:cNvPr id="4" name="Slide Number Placeholder 3"/>
+          <p:cNvSpPr>
+            <a:spLocks noGrp="1"/>
+          </p:cNvSpPr>
+          <p:nvPr>
+            <p:ph type="sldNum" sz="quarter" idx="10"/>
+          </p:nvPr>
+        </p:nvSpPr>
+        <p:spPr/>
+        <p:txBody>
+          <a:bodyPr/>
+          <a:lstStyle/>
+          <a:p>
+            <a:fld id="{F7021451-1387-4CA6-816F-3879F97B5CBC}" type="slidenum">
+              <a:rPr lang="en-US"/>
+              <a:t>17</a:t>
+            </a:fld>
+            <a:endParaRPr lang="en-US"/>
+          </a:p>
+        </p:txBody>
+      </p:sp>
+    </p:spTree>
+    <p:extLst>
+      <p:ext uri="{BB962C8B-B14F-4D97-AF65-F5344CB8AC3E}">
+        <p14:creationId xmlns:p14="http://schemas.microsoft.com/office/powerpoint/2010/main" val="1024086991"/>
+      </p:ext>
+    </p:extLst>
+  </p:cSld>
+  <p:clrMapOvr>
+    <a:masterClrMapping/>
+  </p:clrMapOvr>
+</p:notes>
+</file>
+
+<file path=ppt/notesSlides/notesSlide18.xml><?xml version="1.0" encoding="utf-8"?>
+<p:notes xmlns:a="http://schemas.openxmlformats.org/drawingml/2006/main" xmlns:r="http://schemas.openxmlformats.org/officeDocument/2006/relationships" xmlns:p="http://schemas.openxmlformats.org/presentationml/2006/main">
+  <p:cSld>
+    <p:spTree>
+      <p:nvGrpSpPr>
+        <p:cNvPr id="1" name=""/>
+        <p:cNvGrpSpPr/>
+        <p:nvPr/>
+      </p:nvGrpSpPr>
+      <p:grpSpPr>
+        <a:xfrm>
+          <a:off x="0" y="0"/>
+          <a:ext cx="0" cy="0"/>
+          <a:chOff x="0" y="0"/>
+          <a:chExt cx="0" cy="0"/>
+        </a:xfrm>
+      </p:grpSpPr>
+      <p:sp>
+        <p:nvSpPr>
+          <p:cNvPr id="2" name="Slide Image Placeholder 1"/>
+          <p:cNvSpPr>
+            <a:spLocks noGrp="1" noRot="1" noChangeAspect="1"/>
+          </p:cNvSpPr>
+          <p:nvPr>
+            <p:ph type="sldImg"/>
+          </p:nvPr>
+        </p:nvSpPr>
+        <p:spPr/>
+      </p:sp>
+      <p:sp>
+        <p:nvSpPr>
+          <p:cNvPr id="3" name="Notes Placeholder 2"/>
+          <p:cNvSpPr>
+            <a:spLocks noGrp="1"/>
+          </p:cNvSpPr>
+          <p:nvPr>
+            <p:ph type="body" idx="1"/>
+          </p:nvPr>
+        </p:nvSpPr>
+        <p:spPr/>
+        <p:txBody>
+          <a:bodyPr/>
+          <a:lstStyle/>
+          <a:p>
+            <a:r>
+              <a:rPr lang="en-US" dirty="0"/>
+              <a:t>Com garantia de otimalidade, porque a busca usada aqui e A* com h_max. Se perguntarem o tempo: pouco mais de um segundo e meio.</a:t>
+            </a:r>
+            <a:endParaRPr lang="en-US" dirty="0"/>
+          </a:p>
+        </p:txBody>
+      </p:sp>
+      <p:sp>
+        <p:nvSpPr>
+          <p:cNvPr id="4" name="Slide Number Placeholder 3"/>
+          <p:cNvSpPr>
+            <a:spLocks noGrp="1"/>
+          </p:cNvSpPr>
+          <p:nvPr>
+            <p:ph type="sldNum" sz="quarter" idx="10"/>
+          </p:nvPr>
+        </p:nvSpPr>
+        <p:spPr/>
+        <p:txBody>
+          <a:bodyPr/>
+          <a:lstStyle/>
+          <a:p>
+            <a:fld id="{F7021451-1387-4CA6-816F-3879F97B5CBC}" type="slidenum">
+              <a:rPr lang="en-US"/>
+              <a:t>18</a:t>
+            </a:fld>
+            <a:endParaRPr lang="en-US"/>
+          </a:p>
+        </p:txBody>
+      </p:sp>
+    </p:spTree>
+    <p:extLst>
+      <p:ext uri="{BB962C8B-B14F-4D97-AF65-F5344CB8AC3E}">
+        <p14:creationId xmlns:p14="http://schemas.microsoft.com/office/powerpoint/2010/main" val="1024086991"/>
+      </p:ext>
+    </p:extLst>
+  </p:cSld>
+  <p:clrMapOvr>
+    <a:masterClrMapping/>
+  </p:clrMapOvr>
+</p:notes>
+</file>
+
+<file path=ppt/notesSlides/notesSlide19.xml><?xml version="1.0" encoding="utf-8"?>
+<p:notes xmlns:a="http://schemas.openxmlformats.org/drawingml/2006/main" xmlns:r="http://schemas.openxmlformats.org/officeDocument/2006/relationships" xmlns:p="http://schemas.openxmlformats.org/presentationml/2006/main">
+  <p:cSld>
+    <p:spTree>
+      <p:nvGrpSpPr>
+        <p:cNvPr id="1" name=""/>
+        <p:cNvGrpSpPr/>
+        <p:nvPr/>
+      </p:nvGrpSpPr>
+      <p:grpSpPr>
+        <a:xfrm>
+          <a:off x="0" y="0"/>
+          <a:ext cx="0" cy="0"/>
+          <a:chOff x="0" y="0"/>
+          <a:chExt cx="0" cy="0"/>
+        </a:xfrm>
+      </p:grpSpPr>
+      <p:sp>
+        <p:nvSpPr>
+          <p:cNvPr id="2" name="Slide Image Placeholder 1"/>
+          <p:cNvSpPr>
+            <a:spLocks noGrp="1" noRot="1" noChangeAspect="1"/>
+          </p:cNvSpPr>
+          <p:nvPr>
+            <p:ph type="sldImg"/>
+          </p:nvPr>
+        </p:nvSpPr>
+        <p:spPr/>
+      </p:sp>
+      <p:sp>
+        <p:nvSpPr>
+          <p:cNvPr id="3" name="Notes Placeholder 2"/>
+          <p:cNvSpPr>
+            <a:spLocks noGrp="1"/>
+          </p:cNvSpPr>
+          <p:nvPr>
+            <p:ph type="body" idx="1"/>
+          </p:nvPr>
+        </p:nvSpPr>
+        <p:spPr/>
+        <p:txBody>
+          <a:bodyPr/>
+          <a:lstStyle/>
+          <a:p>
+            <a:r>
+              <a:rPr lang="en-US" dirty="0"/>
+              <a:t>Fecho da demonstracao. O tracejado terracota sai da parada 2 ate a unidade e volta: e o desvio de reposicao que o planejamento decidiu, e ele cai ENTRE visitas, nao no meio de uma, que era exatamente o erro do executor procedural.</a:t>
+            </a:r>
+            <a:endParaRPr lang="en-US" dirty="0"/>
+          </a:p>
+        </p:txBody>
+      </p:sp>
+      <p:sp>
+        <p:nvSpPr>
+          <p:cNvPr id="4" name="Slide Number Placeholder 3"/>
+          <p:cNvSpPr>
+            <a:spLocks noGrp="1"/>
+          </p:cNvSpPr>
+          <p:nvPr>
+            <p:ph type="sldNum" sz="quarter" idx="10"/>
+          </p:nvPr>
+        </p:nvSpPr>
+        <p:spPr/>
+        <p:txBody>
+          <a:bodyPr/>
+          <a:lstStyle/>
+          <a:p>
+            <a:fld id="{F7021451-1387-4CA6-816F-3879F97B5CBC}" type="slidenum">
+              <a:rPr lang="en-US"/>
+              <a:t>19</a:t>
             </a:fld>
             <a:endParaRPr lang="en-US"/>
           </a:p>
@@ -1067,6 +1513,94 @@
             <a:fld id="{F7021451-1387-4CA6-816F-3879F97B5CBC}" type="slidenum">
               <a:rPr lang="en-US"/>
               <a:t>2</a:t>
+            </a:fld>
+            <a:endParaRPr lang="en-US"/>
+          </a:p>
+        </p:txBody>
+      </p:sp>
+    </p:spTree>
+    <p:extLst>
+      <p:ext uri="{BB962C8B-B14F-4D97-AF65-F5344CB8AC3E}">
+        <p14:creationId xmlns:p14="http://schemas.microsoft.com/office/powerpoint/2010/main" val="1024086991"/>
+      </p:ext>
+    </p:extLst>
+  </p:cSld>
+  <p:clrMapOvr>
+    <a:masterClrMapping/>
+  </p:clrMapOvr>
+</p:notes>
+</file>
+
+<file path=ppt/notesSlides/notesSlide20.xml><?xml version="1.0" encoding="utf-8"?>
+<p:notes xmlns:a="http://schemas.openxmlformats.org/drawingml/2006/main" xmlns:r="http://schemas.openxmlformats.org/officeDocument/2006/relationships" xmlns:p="http://schemas.openxmlformats.org/presentationml/2006/main">
+  <p:cSld>
+    <p:spTree>
+      <p:nvGrpSpPr>
+        <p:cNvPr id="1" name=""/>
+        <p:cNvGrpSpPr/>
+        <p:nvPr/>
+      </p:nvGrpSpPr>
+      <p:grpSpPr>
+        <a:xfrm>
+          <a:off x="0" y="0"/>
+          <a:ext cx="0" cy="0"/>
+          <a:chOff x="0" y="0"/>
+          <a:chExt cx="0" cy="0"/>
+        </a:xfrm>
+      </p:grpSpPr>
+      <p:sp>
+        <p:nvSpPr>
+          <p:cNvPr id="2" name="Slide Image Placeholder 1"/>
+          <p:cNvSpPr>
+            <a:spLocks noGrp="1" noRot="1" noChangeAspect="1"/>
+          </p:cNvSpPr>
+          <p:nvPr>
+            <p:ph type="sldImg"/>
+          </p:nvPr>
+        </p:nvSpPr>
+        <p:spPr/>
+      </p:sp>
+      <p:sp>
+        <p:nvSpPr>
+          <p:cNvPr id="3" name="Notes Placeholder 2"/>
+          <p:cNvSpPr>
+            <a:spLocks noGrp="1"/>
+          </p:cNvSpPr>
+          <p:nvPr>
+            <p:ph type="body" idx="1"/>
+          </p:nvPr>
+        </p:nvSpPr>
+        <p:spPr/>
+        <p:txBody>
+          <a:bodyPr/>
+          <a:lstStyle/>
+          <a:p>
+            <a:r>
+              <a:rPr lang="en-US" dirty="0"/>
+              <a:t>Fecho. O trunfo do trabalho nao e ter usado Planning. E termos medido COMO ele ajuda neste problema, inclusive descobrindo que a resposta nao era a que esperavamos. Se a banca perguntar o que sobrou: declaratividade com efeito medido, e prova de inviabilidade. Se perguntar o que caiu: economia de tempo e exclusividade de capacidade. E a frase final: nenhuma das duas metades sozinha resolve.</a:t>
+            </a:r>
+            <a:endParaRPr lang="en-US" dirty="0"/>
+          </a:p>
+        </p:txBody>
+      </p:sp>
+      <p:sp>
+        <p:nvSpPr>
+          <p:cNvPr id="4" name="Slide Number Placeholder 3"/>
+          <p:cNvSpPr>
+            <a:spLocks noGrp="1"/>
+          </p:cNvSpPr>
+          <p:nvPr>
+            <p:ph type="sldNum" sz="quarter" idx="10"/>
+          </p:nvPr>
+        </p:nvSpPr>
+        <p:spPr/>
+        <p:txBody>
+          <a:bodyPr/>
+          <a:lstStyle/>
+          <a:p>
+            <a:fld id="{F7021451-1387-4CA6-816F-3879F97B5CBC}" type="slidenum">
+              <a:rPr lang="en-US"/>
+              <a:t>20</a:t>
             </a:fld>
             <a:endParaRPr lang="en-US"/>
           </a:p>
@@ -4045,7 +4579,7 @@
                 <a:ea typeface="Calibri" pitchFamily="34" charset="-122"/>
                 <a:cs typeface="Calibri" pitchFamily="34" charset="-120"/>
               </a:rPr>
-              <a:t>DEMONSTRAÇÃO · O SISTEMA RODANDO</a:t>
+              <a:t>DEMONSTRAÇÃO · PONTO DE PARTIDA</a:t>
             </a:r>
             <a:endParaRPr lang="en-US" sz="1300" dirty="0"/>
           </a:p>
@@ -4060,7 +4594,7 @@
         <p:spPr>
           <a:xfrm>
             <a:off x="566928" y="658368"/>
-            <a:ext cx="11055096" cy="658368"/>
+            <a:ext cx="11055096" cy="731520"/>
           </a:xfrm>
           <a:prstGeom prst="rect">
             <a:avLst/>
@@ -4087,15 +4621,42 @@
                 <a:ea typeface="Cambria" pitchFamily="34" charset="-122"/>
                 <a:cs typeface="Cambria" pitchFamily="34" charset="-120"/>
               </a:rPr>
-              <a:t>Da microárea inteira até o roteiro do agente</a:t>
+              <a:t>A microárea inteira</a:t>
             </a:r>
             <a:endParaRPr lang="en-US" sz="3400" dirty="0"/>
           </a:p>
         </p:txBody>
+      </p:sp>
+      <p:sp>
+        <p:nvSpPr>
+          <p:cNvPr id="5" name="Shape 2"/>
+          <p:cNvSpPr/>
+          <p:nvPr/>
+        </p:nvSpPr>
+        <p:spPr>
+          <a:xfrm>
+            <a:off x="512064" y="1517904"/>
+            <a:ext cx="6510528" cy="4773168"/>
+          </a:xfrm>
+          <a:prstGeom prst="roundRect">
+            <a:avLst>
+              <a:gd name="adj" fmla="val 1916"/>
+            </a:avLst>
+          </a:prstGeom>
+          <a:solidFill>
+            <a:srgbClr val="FFFDF8"/>
+          </a:solidFill>
+          <a:ln w="12700">
+            <a:solidFill>
+              <a:srgbClr val="E6DCCB"/>
+            </a:solidFill>
+            <a:prstDash val="solid"/>
+          </a:ln>
+        </p:spPr>
       </p:sp>
       <p:pic>
         <p:nvPicPr>
-          <p:cNvPr id="5" name="Image 0" descr="C:\Users\Gabriel\AppData\Local\Temp\claude\c--Users-Gabriel-Desktop-Escola-Trabalho-Faculdade-UFRGS-5--semestre-PCI-Projeto-2\359d3c76-5657-4f72-80a1-7afef4a55908\scratchpad\passos\corte\passo0.jpg">    </p:cNvPr>
+          <p:cNvPr id="6" name="Image 0" descr="apresentacao\3\passos\passo0.jpg">    </p:cNvPr>
           <p:cNvPicPr>
             <a:picLocks noChangeAspect="1"/>
           </p:cNvPicPr>
@@ -4109,8 +4670,8 @@
         </p:blipFill>
         <p:spPr>
           <a:xfrm>
-            <a:off x="1339596" y="1517904"/>
-            <a:ext cx="2212848" cy="1609344"/>
+            <a:off x="566928" y="1572768"/>
+            <a:ext cx="6400800" cy="4663440"/>
           </a:xfrm>
           <a:prstGeom prst="rect">
             <a:avLst/>
@@ -4119,431 +4680,14 @@
       </p:pic>
       <p:sp>
         <p:nvSpPr>
-          <p:cNvPr id="6" name="Text 2"/>
-          <p:cNvSpPr txBox="1"/>
-          <p:nvPr/>
-        </p:nvSpPr>
-        <p:spPr>
-          <a:xfrm>
-            <a:off x="1339596" y="3163824"/>
-            <a:ext cx="2212848" cy="365760"/>
-          </a:xfrm>
-          <a:prstGeom prst="rect">
-            <a:avLst/>
-          </a:prstGeom>
-          <a:noFill/>
-          <a:ln/>
-        </p:spPr>
-        <p:txBody>
-          <a:bodyPr wrap="square" rtlCol="0" anchor="ctr"/>
-          <a:lstStyle/>
-          <a:p>
-            <a:pPr algn="ctr" indent="0" marL="0">
-              <a:buNone/>
-            </a:pPr>
-            <a:r>
-              <a:rPr lang="en-US" sz="1300" dirty="0">
-                <a:solidFill>
-                  <a:srgbClr val="8A7A67"/>
-                </a:solidFill>
-                <a:latin typeface="Calibri" pitchFamily="34" charset="0"/>
-                <a:ea typeface="Calibri" pitchFamily="34" charset="-122"/>
-                <a:cs typeface="Calibri" pitchFamily="34" charset="-120"/>
-              </a:rPr>
-              <a:t>1. a microárea inteira</a:t>
-            </a:r>
-            <a:endParaRPr lang="en-US" sz="1300" dirty="0"/>
-          </a:p>
-        </p:txBody>
-      </p:sp>
-      <p:pic>
-        <p:nvPicPr>
-          <p:cNvPr id="7" name="Image 1" descr="C:\Users\Gabriel\AppData\Local\Temp\claude\c--Users-Gabriel-Desktop-Escola-Trabalho-Faculdade-UFRGS-5--semestre-PCI-Projeto-2\359d3c76-5657-4f72-80a1-7afef4a55908\scratchpad\passos\corte\passo1.jpg">    </p:cNvPr>
-          <p:cNvPicPr>
-            <a:picLocks noChangeAspect="1"/>
-          </p:cNvPicPr>
-          <p:nvPr/>
-        </p:nvPicPr>
-        <p:blipFill>
-          <a:blip r:embed="rId3"/>
-          <a:stretch>
-            <a:fillRect/>
-          </a:stretch>
-        </p:blipFill>
-        <p:spPr>
-          <a:xfrm>
-            <a:off x="3771900" y="1517904"/>
-            <a:ext cx="2212848" cy="1609344"/>
-          </a:xfrm>
-          <a:prstGeom prst="rect">
-            <a:avLst/>
-          </a:prstGeom>
-        </p:spPr>
-      </p:pic>
-      <p:sp>
-        <p:nvSpPr>
-          <p:cNvPr id="8" name="Text 3"/>
-          <p:cNvSpPr txBox="1"/>
-          <p:nvPr/>
-        </p:nvSpPr>
-        <p:spPr>
-          <a:xfrm>
-            <a:off x="3771900" y="3163824"/>
-            <a:ext cx="2212848" cy="365760"/>
-          </a:xfrm>
-          <a:prstGeom prst="rect">
-            <a:avLst/>
-          </a:prstGeom>
-          <a:noFill/>
-          <a:ln/>
-        </p:spPr>
-        <p:txBody>
-          <a:bodyPr wrap="square" rtlCol="0" anchor="ctr"/>
-          <a:lstStyle/>
-          <a:p>
-            <a:pPr algn="ctr" indent="0" marL="0">
-              <a:buNone/>
-            </a:pPr>
-            <a:r>
-              <a:rPr lang="en-US" sz="1300" dirty="0">
-                <a:solidFill>
-                  <a:srgbClr val="8A7A67"/>
-                </a:solidFill>
-                <a:latin typeface="Calibri" pitchFamily="34" charset="0"/>
-                <a:ea typeface="Calibri" pitchFamily="34" charset="-122"/>
-                <a:cs typeface="Calibri" pitchFamily="34" charset="-120"/>
-              </a:rPr>
-              <a:t>2. seleção do turno</a:t>
-            </a:r>
-            <a:endParaRPr lang="en-US" sz="1300" dirty="0"/>
-          </a:p>
-        </p:txBody>
-      </p:sp>
-      <p:pic>
-        <p:nvPicPr>
-          <p:cNvPr id="9" name="Image 2" descr="C:\Users\Gabriel\AppData\Local\Temp\claude\c--Users-Gabriel-Desktop-Escola-Trabalho-Faculdade-UFRGS-5--semestre-PCI-Projeto-2\359d3c76-5657-4f72-80a1-7afef4a55908\scratchpad\passos\corte\passo2.jpg">    </p:cNvPr>
-          <p:cNvPicPr>
-            <a:picLocks noChangeAspect="1"/>
-          </p:cNvPicPr>
-          <p:nvPr/>
-        </p:nvPicPr>
-        <p:blipFill>
-          <a:blip r:embed="rId4"/>
-          <a:stretch>
-            <a:fillRect/>
-          </a:stretch>
-        </p:blipFill>
-        <p:spPr>
-          <a:xfrm>
-            <a:off x="6204204" y="1517904"/>
-            <a:ext cx="2212848" cy="1609344"/>
-          </a:xfrm>
-          <a:prstGeom prst="rect">
-            <a:avLst/>
-          </a:prstGeom>
-        </p:spPr>
-      </p:pic>
-      <p:sp>
-        <p:nvSpPr>
-          <p:cNvPr id="10" name="Text 4"/>
-          <p:cNvSpPr txBox="1"/>
-          <p:nvPr/>
-        </p:nvSpPr>
-        <p:spPr>
-          <a:xfrm>
-            <a:off x="6204204" y="3163824"/>
-            <a:ext cx="2212848" cy="365760"/>
-          </a:xfrm>
-          <a:prstGeom prst="rect">
-            <a:avLst/>
-          </a:prstGeom>
-          <a:noFill/>
-          <a:ln/>
-        </p:spPr>
-        <p:txBody>
-          <a:bodyPr wrap="square" rtlCol="0" anchor="ctr"/>
-          <a:lstStyle/>
-          <a:p>
-            <a:pPr algn="ctr" indent="0" marL="0">
-              <a:buNone/>
-            </a:pPr>
-            <a:r>
-              <a:rPr lang="en-US" sz="1300" dirty="0">
-                <a:solidFill>
-                  <a:srgbClr val="8A7A67"/>
-                </a:solidFill>
-                <a:latin typeface="Calibri" pitchFamily="34" charset="0"/>
-                <a:ea typeface="Calibri" pitchFamily="34" charset="-122"/>
-                <a:cs typeface="Calibri" pitchFamily="34" charset="-120"/>
-              </a:rPr>
-              <a:t>3. rota candidata</a:t>
-            </a:r>
-            <a:endParaRPr lang="en-US" sz="1300" dirty="0"/>
-          </a:p>
-        </p:txBody>
-      </p:sp>
-      <p:pic>
-        <p:nvPicPr>
-          <p:cNvPr id="11" name="Image 3" descr="C:\Users\Gabriel\AppData\Local\Temp\claude\c--Users-Gabriel-Desktop-Escola-Trabalho-Faculdade-UFRGS-5--semestre-PCI-Projeto-2\359d3c76-5657-4f72-80a1-7afef4a55908\scratchpad\passos\corte\passo3.jpg">    </p:cNvPr>
-          <p:cNvPicPr>
-            <a:picLocks noChangeAspect="1"/>
-          </p:cNvPicPr>
-          <p:nvPr/>
-        </p:nvPicPr>
-        <p:blipFill>
-          <a:blip r:embed="rId5"/>
-          <a:stretch>
-            <a:fillRect/>
-          </a:stretch>
-        </p:blipFill>
-        <p:spPr>
-          <a:xfrm>
-            <a:off x="8636508" y="1517904"/>
-            <a:ext cx="2212848" cy="1609344"/>
-          </a:xfrm>
-          <a:prstGeom prst="rect">
-            <a:avLst/>
-          </a:prstGeom>
-        </p:spPr>
-      </p:pic>
-      <p:sp>
-        <p:nvSpPr>
-          <p:cNvPr id="12" name="Text 5"/>
-          <p:cNvSpPr txBox="1"/>
-          <p:nvPr/>
-        </p:nvSpPr>
-        <p:spPr>
-          <a:xfrm>
-            <a:off x="8636508" y="3163824"/>
-            <a:ext cx="2212848" cy="365760"/>
-          </a:xfrm>
-          <a:prstGeom prst="rect">
-            <a:avLst/>
-          </a:prstGeom>
-          <a:noFill/>
-          <a:ln/>
-        </p:spPr>
-        <p:txBody>
-          <a:bodyPr wrap="square" rtlCol="0" anchor="ctr"/>
-          <a:lstStyle/>
-          <a:p>
-            <a:pPr algn="ctr" indent="0" marL="0">
-              <a:buNone/>
-            </a:pPr>
-            <a:r>
-              <a:rPr lang="en-US" sz="1300" b="1" dirty="0">
-                <a:solidFill>
-                  <a:srgbClr val="B35C38"/>
-                </a:solidFill>
-                <a:latin typeface="Calibri" pitchFamily="34" charset="0"/>
-                <a:ea typeface="Calibri" pitchFamily="34" charset="-122"/>
-                <a:cs typeface="Calibri" pitchFamily="34" charset="-120"/>
-              </a:rPr>
-              <a:t>4. REPROVADA pelo protocolo</a:t>
-            </a:r>
-            <a:endParaRPr lang="en-US" sz="1300" dirty="0"/>
-          </a:p>
-        </p:txBody>
-      </p:sp>
-      <p:pic>
-        <p:nvPicPr>
-          <p:cNvPr id="13" name="Image 4" descr="C:\Users\Gabriel\AppData\Local\Temp\claude\c--Users-Gabriel-Desktop-Escola-Trabalho-Faculdade-UFRGS-5--semestre-PCI-Projeto-2\359d3c76-5657-4f72-80a1-7afef4a55908\scratchpad\passos\corte\passo4.jpg">    </p:cNvPr>
-          <p:cNvPicPr>
-            <a:picLocks noChangeAspect="1"/>
-          </p:cNvPicPr>
-          <p:nvPr/>
-        </p:nvPicPr>
-        <p:blipFill>
-          <a:blip r:embed="rId6"/>
-          <a:stretch>
-            <a:fillRect/>
-          </a:stretch>
-        </p:blipFill>
-        <p:spPr>
-          <a:xfrm>
-            <a:off x="2555748" y="3611880"/>
-            <a:ext cx="2212848" cy="1609344"/>
-          </a:xfrm>
-          <a:prstGeom prst="rect">
-            <a:avLst/>
-          </a:prstGeom>
-        </p:spPr>
-      </p:pic>
-      <p:sp>
-        <p:nvSpPr>
-          <p:cNvPr id="14" name="Text 6"/>
-          <p:cNvSpPr txBox="1"/>
-          <p:nvPr/>
-        </p:nvSpPr>
-        <p:spPr>
-          <a:xfrm>
-            <a:off x="2555748" y="5257800"/>
-            <a:ext cx="2212848" cy="365760"/>
-          </a:xfrm>
-          <a:prstGeom prst="rect">
-            <a:avLst/>
-          </a:prstGeom>
-          <a:noFill/>
-          <a:ln/>
-        </p:spPr>
-        <p:txBody>
-          <a:bodyPr wrap="square" rtlCol="0" anchor="ctr"/>
-          <a:lstStyle/>
-          <a:p>
-            <a:pPr algn="ctr" indent="0" marL="0">
-              <a:buNone/>
-            </a:pPr>
-            <a:r>
-              <a:rPr lang="en-US" sz="1300" dirty="0">
-                <a:solidFill>
-                  <a:srgbClr val="8A7A67"/>
-                </a:solidFill>
-                <a:latin typeface="Calibri" pitchFamily="34" charset="0"/>
-                <a:ea typeface="Calibri" pitchFamily="34" charset="-122"/>
-                <a:cs typeface="Calibri" pitchFamily="34" charset="-120"/>
-              </a:rPr>
-              <a:t>5. outra rota, mesma distância</a:t>
-            </a:r>
-            <a:endParaRPr lang="en-US" sz="1300" dirty="0"/>
-          </a:p>
-        </p:txBody>
-      </p:sp>
-      <p:pic>
-        <p:nvPicPr>
-          <p:cNvPr id="15" name="Image 5" descr="C:\Users\Gabriel\AppData\Local\Temp\claude\c--Users-Gabriel-Desktop-Escola-Trabalho-Faculdade-UFRGS-5--semestre-PCI-Projeto-2\359d3c76-5657-4f72-80a1-7afef4a55908\scratchpad\passos\corte\passo5.jpg">    </p:cNvPr>
-          <p:cNvPicPr>
-            <a:picLocks noChangeAspect="1"/>
-          </p:cNvPicPr>
-          <p:nvPr/>
-        </p:nvPicPr>
-        <p:blipFill>
-          <a:blip r:embed="rId7"/>
-          <a:stretch>
-            <a:fillRect/>
-          </a:stretch>
-        </p:blipFill>
-        <p:spPr>
-          <a:xfrm>
-            <a:off x="4988052" y="3611880"/>
-            <a:ext cx="2212848" cy="1609344"/>
-          </a:xfrm>
-          <a:prstGeom prst="rect">
-            <a:avLst/>
-          </a:prstGeom>
-        </p:spPr>
-      </p:pic>
-      <p:sp>
-        <p:nvSpPr>
-          <p:cNvPr id="16" name="Text 7"/>
-          <p:cNvSpPr txBox="1"/>
-          <p:nvPr/>
-        </p:nvSpPr>
-        <p:spPr>
-          <a:xfrm>
-            <a:off x="4988052" y="5257800"/>
-            <a:ext cx="2212848" cy="365760"/>
-          </a:xfrm>
-          <a:prstGeom prst="rect">
-            <a:avLst/>
-          </a:prstGeom>
-          <a:noFill/>
-          <a:ln/>
-        </p:spPr>
-        <p:txBody>
-          <a:bodyPr wrap="square" rtlCol="0" anchor="ctr"/>
-          <a:lstStyle/>
-          <a:p>
-            <a:pPr algn="ctr" indent="0" marL="0">
-              <a:buNone/>
-            </a:pPr>
-            <a:r>
-              <a:rPr lang="en-US" sz="1300" dirty="0">
-                <a:solidFill>
-                  <a:srgbClr val="8A7A67"/>
-                </a:solidFill>
-                <a:latin typeface="Calibri" pitchFamily="34" charset="0"/>
-                <a:ea typeface="Calibri" pitchFamily="34" charset="-122"/>
-                <a:cs typeface="Calibri" pitchFamily="34" charset="-120"/>
-              </a:rPr>
-              <a:t>6. aprovada</a:t>
-            </a:r>
-            <a:endParaRPr lang="en-US" sz="1300" dirty="0"/>
-          </a:p>
-        </p:txBody>
-      </p:sp>
-      <p:pic>
-        <p:nvPicPr>
-          <p:cNvPr id="17" name="Image 6" descr="C:\Users\Gabriel\AppData\Local\Temp\claude\c--Users-Gabriel-Desktop-Escola-Trabalho-Faculdade-UFRGS-5--semestre-PCI-Projeto-2\359d3c76-5657-4f72-80a1-7afef4a55908\scratchpad\passos\corte\passo6.jpg">    </p:cNvPr>
-          <p:cNvPicPr>
-            <a:picLocks noChangeAspect="1"/>
-          </p:cNvPicPr>
-          <p:nvPr/>
-        </p:nvPicPr>
-        <p:blipFill>
-          <a:blip r:embed="rId8"/>
-          <a:stretch>
-            <a:fillRect/>
-          </a:stretch>
-        </p:blipFill>
-        <p:spPr>
-          <a:xfrm>
-            <a:off x="7420356" y="3611880"/>
-            <a:ext cx="2212848" cy="1609344"/>
-          </a:xfrm>
-          <a:prstGeom prst="rect">
-            <a:avLst/>
-          </a:prstGeom>
-        </p:spPr>
-      </p:pic>
-      <p:sp>
-        <p:nvSpPr>
-          <p:cNvPr id="18" name="Text 8"/>
-          <p:cNvSpPr txBox="1"/>
-          <p:nvPr/>
-        </p:nvSpPr>
-        <p:spPr>
-          <a:xfrm>
-            <a:off x="7420356" y="5257800"/>
-            <a:ext cx="2212848" cy="365760"/>
-          </a:xfrm>
-          <a:prstGeom prst="rect">
-            <a:avLst/>
-          </a:prstGeom>
-          <a:noFill/>
-          <a:ln/>
-        </p:spPr>
-        <p:txBody>
-          <a:bodyPr wrap="square" rtlCol="0" anchor="ctr"/>
-          <a:lstStyle/>
-          <a:p>
-            <a:pPr algn="ctr" indent="0" marL="0">
-              <a:buNone/>
-            </a:pPr>
-            <a:r>
-              <a:rPr lang="en-US" sz="1300" dirty="0">
-                <a:solidFill>
-                  <a:srgbClr val="8A7A67"/>
-                </a:solidFill>
-                <a:latin typeface="Calibri" pitchFamily="34" charset="0"/>
-                <a:ea typeface="Calibri" pitchFamily="34" charset="-122"/>
-                <a:cs typeface="Calibri" pitchFamily="34" charset="-120"/>
-              </a:rPr>
-              <a:t>7. o roteiro final</a:t>
-            </a:r>
-            <a:endParaRPr lang="en-US" sz="1300" dirty="0"/>
-          </a:p>
-        </p:txBody>
-      </p:sp>
-      <p:sp>
-        <p:nvSpPr>
-          <p:cNvPr id="19" name="Text 9"/>
-          <p:cNvSpPr txBox="1"/>
-          <p:nvPr/>
-        </p:nvSpPr>
-        <p:spPr>
-          <a:xfrm>
-            <a:off x="566928" y="5614416"/>
-            <a:ext cx="11055096" cy="566928"/>
+          <p:cNvPr id="7" name="Text 3"/>
+          <p:cNvSpPr txBox="1"/>
+          <p:nvPr/>
+        </p:nvSpPr>
+        <p:spPr>
+          <a:xfrm>
+            <a:off x="7379208" y="1691640"/>
+            <a:ext cx="4242816" cy="2286000"/>
           </a:xfrm>
           <a:prstGeom prst="rect">
             <a:avLst/>
@@ -4556,10 +4700,86 @@
           <a:lstStyle/>
           <a:p>
             <a:pPr indent="0" marL="0">
-              <a:buNone/>
-            </a:pPr>
-            <a:r>
-              <a:rPr lang="en-US" sz="1900" dirty="0">
+              <a:lnSpc>
+                <a:spcPct val="114000"/>
+              </a:lnSpc>
+              <a:buNone/>
+            </a:pPr>
+            <a:r>
+              <a:rPr lang="en-US" sz="1700" dirty="0">
+                <a:solidFill>
+                  <a:srgbClr val="5C4F41"/>
+                </a:solidFill>
+                <a:latin typeface="Calibri" pitchFamily="34" charset="0"/>
+                <a:ea typeface="Calibri" pitchFamily="34" charset="-122"/>
+                <a:cs typeface="Calibri" pitchFamily="34" charset="-120"/>
+              </a:rPr>
+              <a:t>São </a:t>
+            </a:r>
+            <a:pPr indent="0" marL="0">
+              <a:lnSpc>
+                <a:spcPct val="114000"/>
+              </a:lnSpc>
+              <a:buNone/>
+            </a:pPr>
+            <a:r>
+              <a:rPr lang="en-US" sz="1700" b="1" dirty="0">
+                <a:solidFill>
+                  <a:srgbClr val="5C4F41"/>
+                </a:solidFill>
+                <a:latin typeface="Calibri" pitchFamily="34" charset="0"/>
+                <a:ea typeface="Calibri" pitchFamily="34" charset="-122"/>
+                <a:cs typeface="Calibri" pitchFamily="34" charset="-120"/>
+              </a:rPr>
+              <a:t>12 famílias</a:t>
+            </a:r>
+            <a:pPr indent="0" marL="0">
+              <a:lnSpc>
+                <a:spcPct val="114000"/>
+              </a:lnSpc>
+              <a:buNone/>
+            </a:pPr>
+            <a:r>
+              <a:rPr lang="en-US" sz="1700" dirty="0">
+                <a:solidFill>
+                  <a:srgbClr val="5C4F41"/>
+                </a:solidFill>
+                <a:latin typeface="Calibri" pitchFamily="34" charset="0"/>
+                <a:ea typeface="Calibri" pitchFamily="34" charset="-122"/>
+                <a:cs typeface="Calibri" pitchFamily="34" charset="-120"/>
+              </a:rPr>
+              <a:t> cadastradas na microárea, com a unidade de saúde como ponto de partida e de retorno. Uma delas está em urgência alta. Nenhum turno cabe todas elas.</a:t>
+            </a:r>
+            <a:endParaRPr lang="en-US" sz="1700" dirty="0"/>
+          </a:p>
+        </p:txBody>
+      </p:sp>
+      <p:sp>
+        <p:nvSpPr>
+          <p:cNvPr id="8" name="Text 4"/>
+          <p:cNvSpPr txBox="1"/>
+          <p:nvPr/>
+        </p:nvSpPr>
+        <p:spPr>
+          <a:xfrm>
+            <a:off x="7379208" y="4315968"/>
+            <a:ext cx="2121408" cy="685800"/>
+          </a:xfrm>
+          <a:prstGeom prst="rect">
+            <a:avLst/>
+          </a:prstGeom>
+          <a:noFill/>
+          <a:ln/>
+        </p:spPr>
+        <p:txBody>
+          <a:bodyPr wrap="square" rtlCol="0" anchor="t"/>
+          <a:lstStyle/>
+          <a:p>
+            <a:pPr indent="0" marL="0">
+              <a:buNone/>
+            </a:pPr>
+            <a:r>
+              <a:rPr lang="en-US" sz="3200" b="1" dirty="0">
                 <a:solidFill>
                   <a:srgbClr val="33291F"/>
                 </a:solidFill>
@@ -4567,13 +4787,77 @@
                 <a:ea typeface="Cambria" pitchFamily="34" charset="-122"/>
                 <a:cs typeface="Cambria" pitchFamily="34" charset="-120"/>
               </a:rPr>
-              <a:t>As duas rotas candidatas custam os mesmos 94 minutos de caminhada: são a mesma volta percorrida em sentidos opostos. </a:t>
-            </a:r>
-            <a:pPr indent="0" marL="0">
-              <a:buNone/>
-            </a:pPr>
-            <a:r>
-              <a:rPr lang="en-US" sz="1900" b="1" dirty="0">
+              <a:t>12</a:t>
+            </a:r>
+            <a:endParaRPr lang="en-US" sz="3200" dirty="0"/>
+          </a:p>
+        </p:txBody>
+      </p:sp>
+      <p:sp>
+        <p:nvSpPr>
+          <p:cNvPr id="9" name="Text 5"/>
+          <p:cNvSpPr txBox="1"/>
+          <p:nvPr/>
+        </p:nvSpPr>
+        <p:spPr>
+          <a:xfrm>
+            <a:off x="7379208" y="4974336"/>
+            <a:ext cx="2121408" cy="548640"/>
+          </a:xfrm>
+          <a:prstGeom prst="rect">
+            <a:avLst/>
+          </a:prstGeom>
+          <a:noFill/>
+          <a:ln/>
+        </p:spPr>
+        <p:txBody>
+          <a:bodyPr wrap="square" rtlCol="0" anchor="ctr"/>
+          <a:lstStyle/>
+          <a:p>
+            <a:pPr indent="0" marL="0">
+              <a:buNone/>
+            </a:pPr>
+            <a:r>
+              <a:rPr lang="en-US" sz="1100" spc="70" kern="0" dirty="0">
+                <a:solidFill>
+                  <a:srgbClr val="8A7A67"/>
+                </a:solidFill>
+                <a:latin typeface="Calibri" pitchFamily="34" charset="0"/>
+                <a:ea typeface="Calibri" pitchFamily="34" charset="-122"/>
+                <a:cs typeface="Calibri" pitchFamily="34" charset="-120"/>
+              </a:rPr>
+              <a:t>FAMÍLIAS</a:t>
+            </a:r>
+            <a:endParaRPr lang="en-US" sz="1100" dirty="0"/>
+          </a:p>
+        </p:txBody>
+      </p:sp>
+      <p:sp>
+        <p:nvSpPr>
+          <p:cNvPr id="10" name="Text 6"/>
+          <p:cNvSpPr txBox="1"/>
+          <p:nvPr/>
+        </p:nvSpPr>
+        <p:spPr>
+          <a:xfrm>
+            <a:off x="9500616" y="4315968"/>
+            <a:ext cx="2121408" cy="685800"/>
+          </a:xfrm>
+          <a:prstGeom prst="rect">
+            <a:avLst/>
+          </a:prstGeom>
+          <a:noFill/>
+          <a:ln/>
+        </p:spPr>
+        <p:txBody>
+          <a:bodyPr wrap="square" rtlCol="0" anchor="t"/>
+          <a:lstStyle/>
+          <a:p>
+            <a:pPr indent="0" marL="0">
+              <a:buNone/>
+            </a:pPr>
+            <a:r>
+              <a:rPr lang="en-US" sz="3200" b="1" dirty="0">
                 <a:solidFill>
                   <a:srgbClr val="33291F"/>
                 </a:solidFill>
@@ -4581,24 +4865,22 @@
                 <a:ea typeface="Cambria" pitchFamily="34" charset="-122"/>
                 <a:cs typeface="Cambria" pitchFamily="34" charset="-120"/>
               </a:rPr>
-              <a:t>Uma cumpre a norma e a outra não.</a:t>
-            </a:r>
-            <a:endParaRPr lang="en-US" sz="1900" dirty="0"/>
-          </a:p>
-        </p:txBody>
-      </p:sp>
-      <p:sp>
-        <p:nvSpPr>
-          <p:cNvPr id="20" name="Text 10">
-            <a:hlinkClick r:id="rId9" tooltip="abre a demonstracao viva no navegador"/>
-          </p:cNvPr>
-          <p:cNvSpPr txBox="1"/>
-          <p:nvPr/>
-        </p:nvSpPr>
-        <p:spPr>
-          <a:xfrm>
-            <a:off x="566928" y="6236208"/>
-            <a:ext cx="11055096" cy="347472"/>
+              <a:t>1</a:t>
+            </a:r>
+            <a:endParaRPr lang="en-US" sz="3200" dirty="0"/>
+          </a:p>
+        </p:txBody>
+      </p:sp>
+      <p:sp>
+        <p:nvSpPr>
+          <p:cNvPr id="11" name="Text 7"/>
+          <p:cNvSpPr txBox="1"/>
+          <p:nvPr/>
+        </p:nvSpPr>
+        <p:spPr>
+          <a:xfrm>
+            <a:off x="9500616" y="4974336"/>
+            <a:ext cx="2121408" cy="548640"/>
           </a:xfrm>
           <a:prstGeom prst="rect">
             <a:avLst/>
@@ -4614,24 +4896,82 @@
               <a:buNone/>
             </a:pPr>
             <a:r>
-              <a:rPr lang="en-US" sz="1300" b="1" u="sng" dirty="0">
-                <a:solidFill>
-                  <a:srgbClr val="B35C38"/>
-                </a:solidFill>
-                <a:latin typeface="Calibri" pitchFamily="34" charset="0"/>
-                <a:ea typeface="Calibri" pitchFamily="34" charset="-122"/>
-                <a:cs typeface="Calibri" pitchFamily="34" charset="-120"/>
-                <a:hlinkClick r:id="rId9" invalidUrl="" action="" tgtFrame="" tooltip="abre a demonstracao viva no navegador" history="1" highlightClick="0" endSnd="0">
-                  <a:extLst>
-                    <a:ext uri="{A12FA001-AC4F-418D-AE19-62706E023703}">
-                      <ahyp:hlinkClr xmlns:ahyp="http://schemas.microsoft.com/office/drawing/2018/hyperlinkcolor" val="tx"/>
-                    </a:ext>
-                  </a:extLst>
-                </a:hlinkClick>
-              </a:rPr>
-              <a:t>Versão viva, navegável: apresentacao/3/demonstracao-do-pipeline.html</a:t>
-            </a:r>
-            <a:endParaRPr lang="en-US" sz="1300" dirty="0"/>
+              <a:rPr lang="en-US" sz="1100" spc="70" kern="0" dirty="0">
+                <a:solidFill>
+                  <a:srgbClr val="8A7A67"/>
+                </a:solidFill>
+                <a:latin typeface="Calibri" pitchFamily="34" charset="0"/>
+                <a:ea typeface="Calibri" pitchFamily="34" charset="-122"/>
+                <a:cs typeface="Calibri" pitchFamily="34" charset="-120"/>
+              </a:rPr>
+              <a:t>URGÊNCIA ALTA</a:t>
+            </a:r>
+            <a:endParaRPr lang="en-US" sz="1100" dirty="0"/>
+          </a:p>
+        </p:txBody>
+      </p:sp>
+      <p:sp>
+        <p:nvSpPr>
+          <p:cNvPr id="12" name="Shape 8"/>
+          <p:cNvSpPr/>
+          <p:nvPr/>
+        </p:nvSpPr>
+        <p:spPr>
+          <a:xfrm>
+            <a:off x="7379208" y="5394960"/>
+            <a:ext cx="4242816" cy="0"/>
+          </a:xfrm>
+          <a:prstGeom prst="line">
+            <a:avLst/>
+          </a:prstGeom>
+          <a:noFill/>
+          <a:ln w="12700">
+            <a:solidFill>
+              <a:srgbClr val="E6DCCB"/>
+            </a:solidFill>
+            <a:prstDash val="solid"/>
+          </a:ln>
+        </p:spPr>
+      </p:sp>
+      <p:sp>
+        <p:nvSpPr>
+          <p:cNvPr id="13" name="Text 9"/>
+          <p:cNvSpPr txBox="1"/>
+          <p:nvPr/>
+        </p:nvSpPr>
+        <p:spPr>
+          <a:xfrm>
+            <a:off x="7379208" y="5522976"/>
+            <a:ext cx="4242816" cy="1005840"/>
+          </a:xfrm>
+          <a:prstGeom prst="rect">
+            <a:avLst/>
+          </a:prstGeom>
+          <a:noFill/>
+          <a:ln/>
+        </p:spPr>
+        <p:txBody>
+          <a:bodyPr wrap="square" rtlCol="0" anchor="t"/>
+          <a:lstStyle/>
+          <a:p>
+            <a:pPr indent="0" marL="0">
+              <a:lnSpc>
+                <a:spcPct val="112000"/>
+              </a:lnSpc>
+              <a:buNone/>
+            </a:pPr>
+            <a:r>
+              <a:rPr lang="en-US" sz="1700" dirty="0">
+                <a:solidFill>
+                  <a:srgbClr val="33291F"/>
+                </a:solidFill>
+                <a:latin typeface="Cambria" pitchFamily="34" charset="0"/>
+                <a:ea typeface="Cambria" pitchFamily="34" charset="-122"/>
+                <a:cs typeface="Cambria" pitchFamily="34" charset="-120"/>
+              </a:rPr>
+              <a:t>A cor do pino é a urgência: terracota é alta, dourado é média, verde é baixa.</a:t>
+            </a:r>
+            <a:endParaRPr lang="en-US" sz="1700" dirty="0"/>
           </a:p>
         </p:txBody>
       </p:sp>
@@ -4707,7 +5047,7 @@
                 <a:ea typeface="Calibri" pitchFamily="34" charset="-122"/>
                 <a:cs typeface="Calibri" pitchFamily="34" charset="-120"/>
               </a:rPr>
-              <a:t>CONCLUSÃO</a:t>
+              <a:t>DEMONSTRAÇÃO · PASSO 1</a:t>
             </a:r>
             <a:endParaRPr lang="en-US" sz="1300" dirty="0"/>
           </a:p>
@@ -4721,8 +5061,8 @@
         </p:nvSpPr>
         <p:spPr>
           <a:xfrm>
-            <a:off x="566928" y="676656"/>
-            <a:ext cx="11055096" cy="914400"/>
+            <a:off x="566928" y="658368"/>
+            <a:ext cx="11055096" cy="731520"/>
           </a:xfrm>
           <a:prstGeom prst="rect">
             <a:avLst/>
@@ -4741,7 +5081,7 @@
               <a:buNone/>
             </a:pPr>
             <a:r>
-              <a:rPr lang="en-US" sz="4000" b="1" dirty="0">
+              <a:rPr lang="en-US" sz="3400" b="1" dirty="0">
                 <a:solidFill>
                   <a:srgbClr val="33291F"/>
                 </a:solidFill>
@@ -4749,9 +5089,9 @@
                 <a:ea typeface="Cambria" pitchFamily="34" charset="-122"/>
                 <a:cs typeface="Cambria" pitchFamily="34" charset="-120"/>
               </a:rPr>
-              <a:t>A hipótese que sobreviveu aos experimentos</a:t>
-            </a:r>
-            <a:endParaRPr lang="en-US" sz="4000" dirty="0"/>
+              <a:t>Seleção: quem entra no turno</a:t>
+            </a:r>
+            <a:endParaRPr lang="en-US" sz="3400" dirty="0"/>
           </a:p>
         </p:txBody>
       </p:sp>
@@ -4763,12 +5103,1923 @@
         </p:nvSpPr>
         <p:spPr>
           <a:xfrm>
-            <a:off x="566928" y="1783080"/>
-            <a:ext cx="11055096" cy="1828800"/>
+            <a:off x="512064" y="1517904"/>
+            <a:ext cx="6510528" cy="4773168"/>
           </a:xfrm>
           <a:prstGeom prst="roundRect">
             <a:avLst>
-              <a:gd name="adj" fmla="val 7000"/>
+              <a:gd name="adj" fmla="val 1916"/>
+            </a:avLst>
+          </a:prstGeom>
+          <a:solidFill>
+            <a:srgbClr val="FFFDF8"/>
+          </a:solidFill>
+          <a:ln w="12700">
+            <a:solidFill>
+              <a:srgbClr val="E6DCCB"/>
+            </a:solidFill>
+            <a:prstDash val="solid"/>
+          </a:ln>
+        </p:spPr>
+      </p:sp>
+      <p:pic>
+        <p:nvPicPr>
+          <p:cNvPr id="6" name="Image 0" descr="apresentacao\3\passos\passo1.jpg">    </p:cNvPr>
+          <p:cNvPicPr>
+            <a:picLocks noChangeAspect="1"/>
+          </p:cNvPicPr>
+          <p:nvPr/>
+        </p:nvPicPr>
+        <p:blipFill>
+          <a:blip r:embed="rId2"/>
+          <a:stretch>
+            <a:fillRect/>
+          </a:stretch>
+        </p:blipFill>
+        <p:spPr>
+          <a:xfrm>
+            <a:off x="566928" y="1572768"/>
+            <a:ext cx="6400800" cy="4663440"/>
+          </a:xfrm>
+          <a:prstGeom prst="rect">
+            <a:avLst/>
+          </a:prstGeom>
+        </p:spPr>
+      </p:pic>
+      <p:sp>
+        <p:nvSpPr>
+          <p:cNvPr id="7" name="Text 3"/>
+          <p:cNvSpPr txBox="1"/>
+          <p:nvPr/>
+        </p:nvSpPr>
+        <p:spPr>
+          <a:xfrm>
+            <a:off x="7379208" y="1691640"/>
+            <a:ext cx="4242816" cy="2286000"/>
+          </a:xfrm>
+          <a:prstGeom prst="rect">
+            <a:avLst/>
+          </a:prstGeom>
+          <a:noFill/>
+          <a:ln/>
+        </p:spPr>
+        <p:txBody>
+          <a:bodyPr wrap="square" rtlCol="0" anchor="t"/>
+          <a:lstStyle/>
+          <a:p>
+            <a:pPr indent="0" marL="0">
+              <a:lnSpc>
+                <a:spcPct val="114000"/>
+              </a:lnSpc>
+              <a:buNone/>
+            </a:pPr>
+            <a:r>
+              <a:rPr lang="en-US" sz="1700" dirty="0">
+                <a:solidFill>
+                  <a:srgbClr val="5C4F41"/>
+                </a:solidFill>
+                <a:latin typeface="Calibri" pitchFamily="34" charset="0"/>
+                <a:ea typeface="Calibri" pitchFamily="34" charset="-122"/>
+                <a:cs typeface="Calibri" pitchFamily="34" charset="-120"/>
+              </a:rPr>
+              <a:t>A política ordena por prioridade clínica e por atraso em relação ao intervalo máximo, e corta no orçamento de 240 minutos. Entram 6 famílias, e 6 ficam para o próximo turno, apagadas no mapa.</a:t>
+            </a:r>
+            <a:endParaRPr lang="en-US" sz="1700" dirty="0"/>
+          </a:p>
+        </p:txBody>
+      </p:sp>
+      <p:sp>
+        <p:nvSpPr>
+          <p:cNvPr id="8" name="Text 4"/>
+          <p:cNvSpPr txBox="1"/>
+          <p:nvPr/>
+        </p:nvSpPr>
+        <p:spPr>
+          <a:xfrm>
+            <a:off x="7379208" y="4315968"/>
+            <a:ext cx="2121408" cy="685800"/>
+          </a:xfrm>
+          <a:prstGeom prst="rect">
+            <a:avLst/>
+          </a:prstGeom>
+          <a:noFill/>
+          <a:ln/>
+        </p:spPr>
+        <p:txBody>
+          <a:bodyPr wrap="square" rtlCol="0" anchor="t"/>
+          <a:lstStyle/>
+          <a:p>
+            <a:pPr indent="0" marL="0">
+              <a:buNone/>
+            </a:pPr>
+            <a:r>
+              <a:rPr lang="en-US" sz="3200" b="1" dirty="0">
+                <a:solidFill>
+                  <a:srgbClr val="33291F"/>
+                </a:solidFill>
+                <a:latin typeface="Cambria" pitchFamily="34" charset="0"/>
+                <a:ea typeface="Cambria" pitchFamily="34" charset="-122"/>
+                <a:cs typeface="Cambria" pitchFamily="34" charset="-120"/>
+              </a:rPr>
+              <a:t>6</a:t>
+            </a:r>
+            <a:endParaRPr lang="en-US" sz="3200" dirty="0"/>
+          </a:p>
+        </p:txBody>
+      </p:sp>
+      <p:sp>
+        <p:nvSpPr>
+          <p:cNvPr id="9" name="Text 5"/>
+          <p:cNvSpPr txBox="1"/>
+          <p:nvPr/>
+        </p:nvSpPr>
+        <p:spPr>
+          <a:xfrm>
+            <a:off x="7379208" y="4974336"/>
+            <a:ext cx="2121408" cy="548640"/>
+          </a:xfrm>
+          <a:prstGeom prst="rect">
+            <a:avLst/>
+          </a:prstGeom>
+          <a:noFill/>
+          <a:ln/>
+        </p:spPr>
+        <p:txBody>
+          <a:bodyPr wrap="square" rtlCol="0" anchor="ctr"/>
+          <a:lstStyle/>
+          <a:p>
+            <a:pPr indent="0" marL="0">
+              <a:buNone/>
+            </a:pPr>
+            <a:r>
+              <a:rPr lang="en-US" sz="1100" spc="70" kern="0" dirty="0">
+                <a:solidFill>
+                  <a:srgbClr val="8A7A67"/>
+                </a:solidFill>
+                <a:latin typeface="Calibri" pitchFamily="34" charset="0"/>
+                <a:ea typeface="Calibri" pitchFamily="34" charset="-122"/>
+                <a:cs typeface="Calibri" pitchFamily="34" charset="-120"/>
+              </a:rPr>
+              <a:t>NO TURNO</a:t>
+            </a:r>
+            <a:endParaRPr lang="en-US" sz="1100" dirty="0"/>
+          </a:p>
+        </p:txBody>
+      </p:sp>
+      <p:sp>
+        <p:nvSpPr>
+          <p:cNvPr id="10" name="Text 6"/>
+          <p:cNvSpPr txBox="1"/>
+          <p:nvPr/>
+        </p:nvSpPr>
+        <p:spPr>
+          <a:xfrm>
+            <a:off x="9500616" y="4315968"/>
+            <a:ext cx="2121408" cy="685800"/>
+          </a:xfrm>
+          <a:prstGeom prst="rect">
+            <a:avLst/>
+          </a:prstGeom>
+          <a:noFill/>
+          <a:ln/>
+        </p:spPr>
+        <p:txBody>
+          <a:bodyPr wrap="square" rtlCol="0" anchor="t"/>
+          <a:lstStyle/>
+          <a:p>
+            <a:pPr indent="0" marL="0">
+              <a:buNone/>
+            </a:pPr>
+            <a:r>
+              <a:rPr lang="en-US" sz="3200" b="1" dirty="0">
+                <a:solidFill>
+                  <a:srgbClr val="33291F"/>
+                </a:solidFill>
+                <a:latin typeface="Cambria" pitchFamily="34" charset="0"/>
+                <a:ea typeface="Cambria" pitchFamily="34" charset="-122"/>
+                <a:cs typeface="Cambria" pitchFamily="34" charset="-120"/>
+              </a:rPr>
+              <a:t>6</a:t>
+            </a:r>
+            <a:endParaRPr lang="en-US" sz="3200" dirty="0"/>
+          </a:p>
+        </p:txBody>
+      </p:sp>
+      <p:sp>
+        <p:nvSpPr>
+          <p:cNvPr id="11" name="Text 7"/>
+          <p:cNvSpPr txBox="1"/>
+          <p:nvPr/>
+        </p:nvSpPr>
+        <p:spPr>
+          <a:xfrm>
+            <a:off x="9500616" y="4974336"/>
+            <a:ext cx="2121408" cy="548640"/>
+          </a:xfrm>
+          <a:prstGeom prst="rect">
+            <a:avLst/>
+          </a:prstGeom>
+          <a:noFill/>
+          <a:ln/>
+        </p:spPr>
+        <p:txBody>
+          <a:bodyPr wrap="square" rtlCol="0" anchor="ctr"/>
+          <a:lstStyle/>
+          <a:p>
+            <a:pPr indent="0" marL="0">
+              <a:buNone/>
+            </a:pPr>
+            <a:r>
+              <a:rPr lang="en-US" sz="1100" spc="70" kern="0" dirty="0">
+                <a:solidFill>
+                  <a:srgbClr val="8A7A67"/>
+                </a:solidFill>
+                <a:latin typeface="Calibri" pitchFamily="34" charset="0"/>
+                <a:ea typeface="Calibri" pitchFamily="34" charset="-122"/>
+                <a:cs typeface="Calibri" pitchFamily="34" charset="-120"/>
+              </a:rPr>
+              <a:t>ADIADOS</a:t>
+            </a:r>
+            <a:endParaRPr lang="en-US" sz="1100" dirty="0"/>
+          </a:p>
+        </p:txBody>
+      </p:sp>
+      <p:sp>
+        <p:nvSpPr>
+          <p:cNvPr id="12" name="Shape 8"/>
+          <p:cNvSpPr/>
+          <p:nvPr/>
+        </p:nvSpPr>
+        <p:spPr>
+          <a:xfrm>
+            <a:off x="7379208" y="5394960"/>
+            <a:ext cx="4242816" cy="0"/>
+          </a:xfrm>
+          <a:prstGeom prst="line">
+            <a:avLst/>
+          </a:prstGeom>
+          <a:noFill/>
+          <a:ln w="12700">
+            <a:solidFill>
+              <a:srgbClr val="E6DCCB"/>
+            </a:solidFill>
+            <a:prstDash val="solid"/>
+          </a:ln>
+        </p:spPr>
+      </p:sp>
+      <p:sp>
+        <p:nvSpPr>
+          <p:cNvPr id="13" name="Text 9"/>
+          <p:cNvSpPr txBox="1"/>
+          <p:nvPr/>
+        </p:nvSpPr>
+        <p:spPr>
+          <a:xfrm>
+            <a:off x="7379208" y="5522976"/>
+            <a:ext cx="4242816" cy="1005840"/>
+          </a:xfrm>
+          <a:prstGeom prst="rect">
+            <a:avLst/>
+          </a:prstGeom>
+          <a:noFill/>
+          <a:ln/>
+        </p:spPr>
+        <p:txBody>
+          <a:bodyPr wrap="square" rtlCol="0" anchor="t"/>
+          <a:lstStyle/>
+          <a:p>
+            <a:pPr indent="0" marL="0">
+              <a:lnSpc>
+                <a:spcPct val="112000"/>
+              </a:lnSpc>
+              <a:buNone/>
+            </a:pPr>
+            <a:r>
+              <a:rPr lang="en-US" sz="1700" dirty="0">
+                <a:solidFill>
+                  <a:srgbClr val="33291F"/>
+                </a:solidFill>
+                <a:latin typeface="Cambria" pitchFamily="34" charset="0"/>
+                <a:ea typeface="Cambria" pitchFamily="34" charset="-122"/>
+                <a:cs typeface="Cambria" pitchFamily="34" charset="-120"/>
+              </a:rPr>
+              <a:t>Esta camada ainda não sabe nada sobre a lei. Ela só escolhe.</a:t>
+            </a:r>
+            <a:endParaRPr lang="en-US" sz="1700" dirty="0"/>
+          </a:p>
+        </p:txBody>
+      </p:sp>
+    </p:spTree>
+  </p:cSld>
+  <p:clrMapOvr>
+    <a:masterClrMapping/>
+  </p:clrMapOvr>
+</p:sld>
+</file>
+
+<file path=ppt/slides/slide15.xml><?xml version="1.0" encoding="utf-8"?>
+<p:sld xmlns:a="http://schemas.openxmlformats.org/drawingml/2006/main" xmlns:r="http://schemas.openxmlformats.org/officeDocument/2006/relationships" xmlns:p="http://schemas.openxmlformats.org/presentationml/2006/main">
+  <p:cSld name="Slide 15">
+    <p:bg>
+      <p:bgPr>
+        <a:blipFill dpi="0" rotWithShape="1">
+          <a:blip r:embed="rId1">
+            <a:lum/>
+          </a:blip>
+          <a:srcRect/>
+          <a:stretch>
+            <a:fillRect/>
+          </a:stretch>
+        </a:blipFill>
+        <a:effectLst/>
+      </p:bgPr>
+    </p:bg>
+    <p:spTree>
+      <p:nvGrpSpPr>
+        <p:cNvPr id="1" name=""/>
+        <p:cNvGrpSpPr/>
+        <p:nvPr/>
+      </p:nvGrpSpPr>
+      <p:grpSpPr>
+        <a:xfrm>
+          <a:off x="0" y="0"/>
+          <a:ext cx="0" cy="0"/>
+          <a:chOff x="0" y="0"/>
+          <a:chExt cx="0" cy="0"/>
+        </a:xfrm>
+      </p:grpSpPr>
+      <p:sp>
+        <p:nvSpPr>
+          <p:cNvPr id="3" name="Text 0"/>
+          <p:cNvSpPr txBox="1"/>
+          <p:nvPr/>
+        </p:nvSpPr>
+        <p:spPr>
+          <a:xfrm>
+            <a:off x="566928" y="347472"/>
+            <a:ext cx="11055096" cy="292608"/>
+          </a:xfrm>
+          <a:prstGeom prst="rect">
+            <a:avLst/>
+          </a:prstGeom>
+          <a:noFill/>
+          <a:ln/>
+        </p:spPr>
+        <p:txBody>
+          <a:bodyPr wrap="square" rtlCol="0" anchor="ctr"/>
+          <a:lstStyle/>
+          <a:p>
+            <a:pPr indent="0" marL="0">
+              <a:buNone/>
+            </a:pPr>
+            <a:r>
+              <a:rPr lang="en-US" sz="1300" b="1" spc="160" kern="0" dirty="0">
+                <a:solidFill>
+                  <a:srgbClr val="B35C38"/>
+                </a:solidFill>
+                <a:latin typeface="Calibri" pitchFamily="34" charset="0"/>
+                <a:ea typeface="Calibri" pitchFamily="34" charset="-122"/>
+                <a:cs typeface="Calibri" pitchFamily="34" charset="-120"/>
+              </a:rPr>
+              <a:t>DEMONSTRAÇÃO · PASSO 2</a:t>
+            </a:r>
+            <a:endParaRPr lang="en-US" sz="1300" dirty="0"/>
+          </a:p>
+        </p:txBody>
+      </p:sp>
+      <p:sp>
+        <p:nvSpPr>
+          <p:cNvPr id="4" name="Text 1"/>
+          <p:cNvSpPr txBox="1"/>
+          <p:nvPr/>
+        </p:nvSpPr>
+        <p:spPr>
+          <a:xfrm>
+            <a:off x="566928" y="658368"/>
+            <a:ext cx="11055096" cy="731520"/>
+          </a:xfrm>
+          <a:prstGeom prst="rect">
+            <a:avLst/>
+          </a:prstGeom>
+          <a:noFill/>
+          <a:ln/>
+        </p:spPr>
+        <p:txBody>
+          <a:bodyPr wrap="square" rtlCol="0" anchor="t"/>
+          <a:lstStyle/>
+          <a:p>
+            <a:pPr indent="0" marL="0">
+              <a:lnSpc>
+                <a:spcPct val="100000"/>
+              </a:lnSpc>
+              <a:buNone/>
+            </a:pPr>
+            <a:r>
+              <a:rPr lang="en-US" sz="3400" b="1" dirty="0">
+                <a:solidFill>
+                  <a:srgbClr val="33291F"/>
+                </a:solidFill>
+                <a:latin typeface="Cambria" pitchFamily="34" charset="0"/>
+                <a:ea typeface="Cambria" pitchFamily="34" charset="-122"/>
+                <a:cs typeface="Cambria" pitchFamily="34" charset="-120"/>
+              </a:rPr>
+              <a:t>Roteamento: em que ordem visitar</a:t>
+            </a:r>
+            <a:endParaRPr lang="en-US" sz="3400" dirty="0"/>
+          </a:p>
+        </p:txBody>
+      </p:sp>
+      <p:sp>
+        <p:nvSpPr>
+          <p:cNvPr id="5" name="Shape 2"/>
+          <p:cNvSpPr/>
+          <p:nvPr/>
+        </p:nvSpPr>
+        <p:spPr>
+          <a:xfrm>
+            <a:off x="512064" y="1517904"/>
+            <a:ext cx="6510528" cy="4773168"/>
+          </a:xfrm>
+          <a:prstGeom prst="roundRect">
+            <a:avLst>
+              <a:gd name="adj" fmla="val 1916"/>
+            </a:avLst>
+          </a:prstGeom>
+          <a:solidFill>
+            <a:srgbClr val="FFFDF8"/>
+          </a:solidFill>
+          <a:ln w="12700">
+            <a:solidFill>
+              <a:srgbClr val="E6DCCB"/>
+            </a:solidFill>
+            <a:prstDash val="solid"/>
+          </a:ln>
+        </p:spPr>
+      </p:sp>
+      <p:pic>
+        <p:nvPicPr>
+          <p:cNvPr id="6" name="Image 0" descr="apresentacao\3\passos\passo2.jpg">    </p:cNvPr>
+          <p:cNvPicPr>
+            <a:picLocks noChangeAspect="1"/>
+          </p:cNvPicPr>
+          <p:nvPr/>
+        </p:nvPicPr>
+        <p:blipFill>
+          <a:blip r:embed="rId2"/>
+          <a:stretch>
+            <a:fillRect/>
+          </a:stretch>
+        </p:blipFill>
+        <p:spPr>
+          <a:xfrm>
+            <a:off x="566928" y="1572768"/>
+            <a:ext cx="6400800" cy="4663440"/>
+          </a:xfrm>
+          <a:prstGeom prst="rect">
+            <a:avLst/>
+          </a:prstGeom>
+        </p:spPr>
+      </p:pic>
+      <p:sp>
+        <p:nvSpPr>
+          <p:cNvPr id="7" name="Text 3"/>
+          <p:cNvSpPr txBox="1"/>
+          <p:nvPr/>
+        </p:nvSpPr>
+        <p:spPr>
+          <a:xfrm>
+            <a:off x="7379208" y="1691640"/>
+            <a:ext cx="4242816" cy="2286000"/>
+          </a:xfrm>
+          <a:prstGeom prst="rect">
+            <a:avLst/>
+          </a:prstGeom>
+          <a:noFill/>
+          <a:ln/>
+        </p:spPr>
+        <p:txBody>
+          <a:bodyPr wrap="square" rtlCol="0" anchor="t"/>
+          <a:lstStyle/>
+          <a:p>
+            <a:pPr indent="0" marL="0">
+              <a:lnSpc>
+                <a:spcPct val="114000"/>
+              </a:lnSpc>
+              <a:buNone/>
+            </a:pPr>
+            <a:r>
+              <a:rPr lang="en-US" sz="1700" dirty="0">
+                <a:solidFill>
+                  <a:srgbClr val="5C4F41"/>
+                </a:solidFill>
+                <a:latin typeface="Calibri" pitchFamily="34" charset="0"/>
+                <a:ea typeface="Calibri" pitchFamily="34" charset="-122"/>
+                <a:cs typeface="Calibri" pitchFamily="34" charset="-120"/>
+              </a:rPr>
+              <a:t>A camada geométrica devolve uma sequência de paradas com 94 minutos de caminhada. Ela otimiza distância, e só: não sabe o que a lei exige dentro de cada casa, nem que urgência alta tem de ser atendida antes de urgência baixa.</a:t>
+            </a:r>
+            <a:endParaRPr lang="en-US" sz="1700" dirty="0"/>
+          </a:p>
+        </p:txBody>
+      </p:sp>
+      <p:sp>
+        <p:nvSpPr>
+          <p:cNvPr id="8" name="Text 4"/>
+          <p:cNvSpPr txBox="1"/>
+          <p:nvPr/>
+        </p:nvSpPr>
+        <p:spPr>
+          <a:xfrm>
+            <a:off x="7379208" y="4315968"/>
+            <a:ext cx="4242816" cy="685800"/>
+          </a:xfrm>
+          <a:prstGeom prst="rect">
+            <a:avLst/>
+          </a:prstGeom>
+          <a:noFill/>
+          <a:ln/>
+        </p:spPr>
+        <p:txBody>
+          <a:bodyPr wrap="square" rtlCol="0" anchor="t"/>
+          <a:lstStyle/>
+          <a:p>
+            <a:pPr indent="0" marL="0">
+              <a:buNone/>
+            </a:pPr>
+            <a:r>
+              <a:rPr lang="en-US" sz="3200" b="1" dirty="0">
+                <a:solidFill>
+                  <a:srgbClr val="33291F"/>
+                </a:solidFill>
+                <a:latin typeface="Cambria" pitchFamily="34" charset="0"/>
+                <a:ea typeface="Cambria" pitchFamily="34" charset="-122"/>
+                <a:cs typeface="Cambria" pitchFamily="34" charset="-120"/>
+              </a:rPr>
+              <a:t>94</a:t>
+            </a:r>
+            <a:endParaRPr lang="en-US" sz="3200" dirty="0"/>
+          </a:p>
+        </p:txBody>
+      </p:sp>
+      <p:sp>
+        <p:nvSpPr>
+          <p:cNvPr id="9" name="Text 5"/>
+          <p:cNvSpPr txBox="1"/>
+          <p:nvPr/>
+        </p:nvSpPr>
+        <p:spPr>
+          <a:xfrm>
+            <a:off x="7379208" y="4974336"/>
+            <a:ext cx="4242816" cy="548640"/>
+          </a:xfrm>
+          <a:prstGeom prst="rect">
+            <a:avLst/>
+          </a:prstGeom>
+          <a:noFill/>
+          <a:ln/>
+        </p:spPr>
+        <p:txBody>
+          <a:bodyPr wrap="square" rtlCol="0" anchor="ctr"/>
+          <a:lstStyle/>
+          <a:p>
+            <a:pPr indent="0" marL="0">
+              <a:buNone/>
+            </a:pPr>
+            <a:r>
+              <a:rPr lang="en-US" sz="1100" spc="70" kern="0" dirty="0">
+                <a:solidFill>
+                  <a:srgbClr val="8A7A67"/>
+                </a:solidFill>
+                <a:latin typeface="Calibri" pitchFamily="34" charset="0"/>
+                <a:ea typeface="Calibri" pitchFamily="34" charset="-122"/>
+                <a:cs typeface="Calibri" pitchFamily="34" charset="-120"/>
+              </a:rPr>
+              <a:t>MIN DE CAMINHADA</a:t>
+            </a:r>
+            <a:endParaRPr lang="en-US" sz="1100" dirty="0"/>
+          </a:p>
+        </p:txBody>
+      </p:sp>
+      <p:sp>
+        <p:nvSpPr>
+          <p:cNvPr id="10" name="Shape 6"/>
+          <p:cNvSpPr/>
+          <p:nvPr/>
+        </p:nvSpPr>
+        <p:spPr>
+          <a:xfrm>
+            <a:off x="7379208" y="5394960"/>
+            <a:ext cx="4242816" cy="0"/>
+          </a:xfrm>
+          <a:prstGeom prst="line">
+            <a:avLst/>
+          </a:prstGeom>
+          <a:noFill/>
+          <a:ln w="12700">
+            <a:solidFill>
+              <a:srgbClr val="E6DCCB"/>
+            </a:solidFill>
+            <a:prstDash val="solid"/>
+          </a:ln>
+        </p:spPr>
+      </p:sp>
+      <p:sp>
+        <p:nvSpPr>
+          <p:cNvPr id="11" name="Text 7"/>
+          <p:cNvSpPr txBox="1"/>
+          <p:nvPr/>
+        </p:nvSpPr>
+        <p:spPr>
+          <a:xfrm>
+            <a:off x="7379208" y="5522976"/>
+            <a:ext cx="4242816" cy="1005840"/>
+          </a:xfrm>
+          <a:prstGeom prst="rect">
+            <a:avLst/>
+          </a:prstGeom>
+          <a:noFill/>
+          <a:ln/>
+        </p:spPr>
+        <p:txBody>
+          <a:bodyPr wrap="square" rtlCol="0" anchor="t"/>
+          <a:lstStyle/>
+          <a:p>
+            <a:pPr indent="0" marL="0">
+              <a:lnSpc>
+                <a:spcPct val="112000"/>
+              </a:lnSpc>
+              <a:buNone/>
+            </a:pPr>
+            <a:r>
+              <a:rPr lang="en-US" sz="1700" dirty="0">
+                <a:solidFill>
+                  <a:srgbClr val="33291F"/>
+                </a:solidFill>
+                <a:latin typeface="Cambria" pitchFamily="34" charset="0"/>
+                <a:ea typeface="Cambria" pitchFamily="34" charset="-122"/>
+                <a:cs typeface="Cambria" pitchFamily="34" charset="-120"/>
+              </a:rPr>
+              <a:t>A rota entra congelada no passo seguinte.</a:t>
+            </a:r>
+            <a:endParaRPr lang="en-US" sz="1700" dirty="0"/>
+          </a:p>
+        </p:txBody>
+      </p:sp>
+    </p:spTree>
+  </p:cSld>
+  <p:clrMapOvr>
+    <a:masterClrMapping/>
+  </p:clrMapOvr>
+</p:sld>
+</file>
+
+<file path=ppt/slides/slide16.xml><?xml version="1.0" encoding="utf-8"?>
+<p:sld xmlns:a="http://schemas.openxmlformats.org/drawingml/2006/main" xmlns:r="http://schemas.openxmlformats.org/officeDocument/2006/relationships" xmlns:p="http://schemas.openxmlformats.org/presentationml/2006/main">
+  <p:cSld name="Slide 16">
+    <p:bg>
+      <p:bgPr>
+        <a:blipFill dpi="0" rotWithShape="1">
+          <a:blip r:embed="rId1">
+            <a:lum/>
+          </a:blip>
+          <a:srcRect/>
+          <a:stretch>
+            <a:fillRect/>
+          </a:stretch>
+        </a:blipFill>
+        <a:effectLst/>
+      </p:bgPr>
+    </p:bg>
+    <p:spTree>
+      <p:nvGrpSpPr>
+        <p:cNvPr id="1" name=""/>
+        <p:cNvGrpSpPr/>
+        <p:nvPr/>
+      </p:nvGrpSpPr>
+      <p:grpSpPr>
+        <a:xfrm>
+          <a:off x="0" y="0"/>
+          <a:ext cx="0" cy="0"/>
+          <a:chOff x="0" y="0"/>
+          <a:chExt cx="0" cy="0"/>
+        </a:xfrm>
+      </p:grpSpPr>
+      <p:sp>
+        <p:nvSpPr>
+          <p:cNvPr id="3" name="Text 0"/>
+          <p:cNvSpPr txBox="1"/>
+          <p:nvPr/>
+        </p:nvSpPr>
+        <p:spPr>
+          <a:xfrm>
+            <a:off x="566928" y="347472"/>
+            <a:ext cx="11055096" cy="292608"/>
+          </a:xfrm>
+          <a:prstGeom prst="rect">
+            <a:avLst/>
+          </a:prstGeom>
+          <a:noFill/>
+          <a:ln/>
+        </p:spPr>
+        <p:txBody>
+          <a:bodyPr wrap="square" rtlCol="0" anchor="ctr"/>
+          <a:lstStyle/>
+          <a:p>
+            <a:pPr indent="0" marL="0">
+              <a:buNone/>
+            </a:pPr>
+            <a:r>
+              <a:rPr lang="en-US" sz="1300" b="1" spc="160" kern="0" dirty="0">
+                <a:solidFill>
+                  <a:srgbClr val="B35C38"/>
+                </a:solidFill>
+                <a:latin typeface="Calibri" pitchFamily="34" charset="0"/>
+                <a:ea typeface="Calibri" pitchFamily="34" charset="-122"/>
+                <a:cs typeface="Calibri" pitchFamily="34" charset="-120"/>
+              </a:rPr>
+              <a:t>DEMONSTRAÇÃO · PASSO 3</a:t>
+            </a:r>
+            <a:endParaRPr lang="en-US" sz="1300" dirty="0"/>
+          </a:p>
+        </p:txBody>
+      </p:sp>
+      <p:sp>
+        <p:nvSpPr>
+          <p:cNvPr id="4" name="Text 1"/>
+          <p:cNvSpPr txBox="1"/>
+          <p:nvPr/>
+        </p:nvSpPr>
+        <p:spPr>
+          <a:xfrm>
+            <a:off x="566928" y="658368"/>
+            <a:ext cx="11055096" cy="731520"/>
+          </a:xfrm>
+          <a:prstGeom prst="rect">
+            <a:avLst/>
+          </a:prstGeom>
+          <a:noFill/>
+          <a:ln/>
+        </p:spPr>
+        <p:txBody>
+          <a:bodyPr wrap="square" rtlCol="0" anchor="t"/>
+          <a:lstStyle/>
+          <a:p>
+            <a:pPr indent="0" marL="0">
+              <a:lnSpc>
+                <a:spcPct val="100000"/>
+              </a:lnSpc>
+              <a:buNone/>
+            </a:pPr>
+            <a:r>
+              <a:rPr lang="en-US" sz="3400" b="1" dirty="0">
+                <a:solidFill>
+                  <a:srgbClr val="33291F"/>
+                </a:solidFill>
+                <a:latin typeface="Cambria" pitchFamily="34" charset="0"/>
+                <a:ea typeface="Cambria" pitchFamily="34" charset="-122"/>
+                <a:cs typeface="Cambria" pitchFamily="34" charset="-120"/>
+              </a:rPr>
+              <a:t>O protocolo NÃO cabe nesta rota</a:t>
+            </a:r>
+            <a:endParaRPr lang="en-US" sz="3400" dirty="0"/>
+          </a:p>
+        </p:txBody>
+      </p:sp>
+      <p:sp>
+        <p:nvSpPr>
+          <p:cNvPr id="5" name="Shape 2"/>
+          <p:cNvSpPr/>
+          <p:nvPr/>
+        </p:nvSpPr>
+        <p:spPr>
+          <a:xfrm>
+            <a:off x="512064" y="1517904"/>
+            <a:ext cx="6510528" cy="4773168"/>
+          </a:xfrm>
+          <a:prstGeom prst="roundRect">
+            <a:avLst>
+              <a:gd name="adj" fmla="val 1916"/>
+            </a:avLst>
+          </a:prstGeom>
+          <a:solidFill>
+            <a:srgbClr val="FFFDF8"/>
+          </a:solidFill>
+          <a:ln w="12700">
+            <a:solidFill>
+              <a:srgbClr val="E6DCCB"/>
+            </a:solidFill>
+            <a:prstDash val="solid"/>
+          </a:ln>
+        </p:spPr>
+      </p:sp>
+      <p:pic>
+        <p:nvPicPr>
+          <p:cNvPr id="6" name="Image 0" descr="apresentacao\3\passos\passo3.jpg">    </p:cNvPr>
+          <p:cNvPicPr>
+            <a:picLocks noChangeAspect="1"/>
+          </p:cNvPicPr>
+          <p:nvPr/>
+        </p:nvPicPr>
+        <p:blipFill>
+          <a:blip r:embed="rId2"/>
+          <a:stretch>
+            <a:fillRect/>
+          </a:stretch>
+        </p:blipFill>
+        <p:spPr>
+          <a:xfrm>
+            <a:off x="566928" y="1572768"/>
+            <a:ext cx="6400800" cy="4663440"/>
+          </a:xfrm>
+          <a:prstGeom prst="rect">
+            <a:avLst/>
+          </a:prstGeom>
+        </p:spPr>
+      </p:pic>
+      <p:sp>
+        <p:nvSpPr>
+          <p:cNvPr id="7" name="Shape 3"/>
+          <p:cNvSpPr/>
+          <p:nvPr/>
+        </p:nvSpPr>
+        <p:spPr>
+          <a:xfrm>
+            <a:off x="7379208" y="1691640"/>
+            <a:ext cx="3200400" cy="384048"/>
+          </a:xfrm>
+          <a:prstGeom prst="roundRect">
+            <a:avLst>
+              <a:gd name="adj" fmla="val 119048"/>
+            </a:avLst>
+          </a:prstGeom>
+          <a:solidFill>
+            <a:srgbClr val="F3DFD3"/>
+          </a:solidFill>
+          <a:ln w="12700">
+            <a:solidFill>
+              <a:srgbClr val="F3DFD3"/>
+            </a:solidFill>
+            <a:prstDash val="solid"/>
+          </a:ln>
+        </p:spPr>
+      </p:sp>
+      <p:sp>
+        <p:nvSpPr>
+          <p:cNvPr id="8" name="Text 4"/>
+          <p:cNvSpPr txBox="1"/>
+          <p:nvPr/>
+        </p:nvSpPr>
+        <p:spPr>
+          <a:xfrm>
+            <a:off x="7379208" y="1691640"/>
+            <a:ext cx="3200400" cy="384048"/>
+          </a:xfrm>
+          <a:prstGeom prst="rect">
+            <a:avLst/>
+          </a:prstGeom>
+          <a:noFill/>
+          <a:ln/>
+        </p:spPr>
+        <p:txBody>
+          <a:bodyPr wrap="square" rtlCol="0" anchor="ctr"/>
+          <a:lstStyle/>
+          <a:p>
+            <a:pPr algn="ctr" indent="0" marL="0">
+              <a:buNone/>
+            </a:pPr>
+            <a:r>
+              <a:rPr lang="en-US" sz="1300" b="1" dirty="0">
+                <a:solidFill>
+                  <a:srgbClr val="B35C38"/>
+                </a:solidFill>
+                <a:latin typeface="Calibri" pitchFamily="34" charset="0"/>
+                <a:ea typeface="Calibri" pitchFamily="34" charset="-122"/>
+                <a:cs typeface="Calibri" pitchFamily="34" charset="-120"/>
+              </a:rPr>
+              <a:t>rota reprovada pelo protocolo</a:t>
+            </a:r>
+            <a:endParaRPr lang="en-US" sz="1300" dirty="0"/>
+          </a:p>
+        </p:txBody>
+      </p:sp>
+      <p:sp>
+        <p:nvSpPr>
+          <p:cNvPr id="9" name="Text 5"/>
+          <p:cNvSpPr txBox="1"/>
+          <p:nvPr/>
+        </p:nvSpPr>
+        <p:spPr>
+          <a:xfrm>
+            <a:off x="7379208" y="2258568"/>
+            <a:ext cx="4242816" cy="2286000"/>
+          </a:xfrm>
+          <a:prstGeom prst="rect">
+            <a:avLst/>
+          </a:prstGeom>
+          <a:noFill/>
+          <a:ln/>
+        </p:spPr>
+        <p:txBody>
+          <a:bodyPr wrap="square" rtlCol="0" anchor="t"/>
+          <a:lstStyle/>
+          <a:p>
+            <a:pPr indent="0" marL="0">
+              <a:lnSpc>
+                <a:spcPct val="114000"/>
+              </a:lnSpc>
+              <a:buNone/>
+            </a:pPr>
+            <a:r>
+              <a:rPr lang="en-US" sz="1700" dirty="0">
+                <a:solidFill>
+                  <a:srgbClr val="5C4F41"/>
+                </a:solidFill>
+                <a:latin typeface="Calibri" pitchFamily="34" charset="0"/>
+                <a:ea typeface="Calibri" pitchFamily="34" charset="-122"/>
+                <a:cs typeface="Calibri" pitchFamily="34" charset="-120"/>
+              </a:rPr>
+              <a:t>A 1ª parada é </a:t>
+            </a:r>
+            <a:pPr indent="0" marL="0">
+              <a:lnSpc>
+                <a:spcPct val="114000"/>
+              </a:lnSpc>
+              <a:buNone/>
+            </a:pPr>
+            <a:r>
+              <a:rPr lang="en-US" sz="1700" b="1" dirty="0">
+                <a:solidFill>
+                  <a:srgbClr val="5C4F41"/>
+                </a:solidFill>
+                <a:latin typeface="Calibri" pitchFamily="34" charset="0"/>
+                <a:ea typeface="Calibri" pitchFamily="34" charset="-122"/>
+                <a:cs typeface="Calibri" pitchFamily="34" charset="-120"/>
+              </a:rPr>
+              <a:t>p4</a:t>
+            </a:r>
+            <a:pPr indent="0" marL="0">
+              <a:lnSpc>
+                <a:spcPct val="114000"/>
+              </a:lnSpc>
+              <a:buNone/>
+            </a:pPr>
+            <a:r>
+              <a:rPr lang="en-US" sz="1700" dirty="0">
+                <a:solidFill>
+                  <a:srgbClr val="5C4F41"/>
+                </a:solidFill>
+                <a:latin typeface="Calibri" pitchFamily="34" charset="0"/>
+                <a:ea typeface="Calibri" pitchFamily="34" charset="-122"/>
+                <a:cs typeface="Calibri" pitchFamily="34" charset="-120"/>
+              </a:rPr>
+              <a:t>, de urgência baixa, e </a:t>
+            </a:r>
+            <a:pPr indent="0" marL="0">
+              <a:lnSpc>
+                <a:spcPct val="114000"/>
+              </a:lnSpc>
+              <a:buNone/>
+            </a:pPr>
+            <a:r>
+              <a:rPr lang="en-US" sz="1700" b="1" dirty="0">
+                <a:solidFill>
+                  <a:srgbClr val="5C4F41"/>
+                </a:solidFill>
+                <a:latin typeface="Calibri" pitchFamily="34" charset="0"/>
+                <a:ea typeface="Calibri" pitchFamily="34" charset="-122"/>
+                <a:cs typeface="Calibri" pitchFamily="34" charset="-120"/>
+              </a:rPr>
+              <a:t>p7</a:t>
+            </a:r>
+            <a:pPr indent="0" marL="0">
+              <a:lnSpc>
+                <a:spcPct val="114000"/>
+              </a:lnSpc>
+              <a:buNone/>
+            </a:pPr>
+            <a:r>
+              <a:rPr lang="en-US" sz="1700" dirty="0">
+                <a:solidFill>
+                  <a:srgbClr val="5C4F41"/>
+                </a:solidFill>
+                <a:latin typeface="Calibri" pitchFamily="34" charset="0"/>
+                <a:ea typeface="Calibri" pitchFamily="34" charset="-122"/>
+                <a:cs typeface="Calibri" pitchFamily="34" charset="-120"/>
+              </a:rPr>
+              <a:t>, de urgência alta, só viria na 6ª. Com a rota congelada, iniciar uma visita adiável exige que nenhuma urgência alta esteja pendente, e esse contador só baixa quando p7 é atendido.</a:t>
+            </a:r>
+            <a:endParaRPr lang="en-US" sz="1700" dirty="0"/>
+          </a:p>
+        </p:txBody>
+      </p:sp>
+      <p:sp>
+        <p:nvSpPr>
+          <p:cNvPr id="10" name="Text 6"/>
+          <p:cNvSpPr txBox="1"/>
+          <p:nvPr/>
+        </p:nvSpPr>
+        <p:spPr>
+          <a:xfrm>
+            <a:off x="7379208" y="4315968"/>
+            <a:ext cx="2121408" cy="685800"/>
+          </a:xfrm>
+          <a:prstGeom prst="rect">
+            <a:avLst/>
+          </a:prstGeom>
+          <a:noFill/>
+          <a:ln/>
+        </p:spPr>
+        <p:txBody>
+          <a:bodyPr wrap="square" rtlCol="0" anchor="t"/>
+          <a:lstStyle/>
+          <a:p>
+            <a:pPr indent="0" marL="0">
+              <a:buNone/>
+            </a:pPr>
+            <a:r>
+              <a:rPr lang="en-US" sz="3200" b="1" dirty="0">
+                <a:solidFill>
+                  <a:srgbClr val="33291F"/>
+                </a:solidFill>
+                <a:latin typeface="Cambria" pitchFamily="34" charset="0"/>
+                <a:ea typeface="Cambria" pitchFamily="34" charset="-122"/>
+                <a:cs typeface="Cambria" pitchFamily="34" charset="-120"/>
+              </a:rPr>
+              <a:t>50</a:t>
+            </a:r>
+            <a:endParaRPr lang="en-US" sz="3200" dirty="0"/>
+          </a:p>
+        </p:txBody>
+      </p:sp>
+      <p:sp>
+        <p:nvSpPr>
+          <p:cNvPr id="11" name="Text 7"/>
+          <p:cNvSpPr txBox="1"/>
+          <p:nvPr/>
+        </p:nvSpPr>
+        <p:spPr>
+          <a:xfrm>
+            <a:off x="7379208" y="4974336"/>
+            <a:ext cx="2121408" cy="548640"/>
+          </a:xfrm>
+          <a:prstGeom prst="rect">
+            <a:avLst/>
+          </a:prstGeom>
+          <a:noFill/>
+          <a:ln/>
+        </p:spPr>
+        <p:txBody>
+          <a:bodyPr wrap="square" rtlCol="0" anchor="ctr"/>
+          <a:lstStyle/>
+          <a:p>
+            <a:pPr indent="0" marL="0">
+              <a:buNone/>
+            </a:pPr>
+            <a:r>
+              <a:rPr lang="en-US" sz="1100" spc="70" kern="0" dirty="0">
+                <a:solidFill>
+                  <a:srgbClr val="8A7A67"/>
+                </a:solidFill>
+                <a:latin typeface="Calibri" pitchFamily="34" charset="0"/>
+                <a:ea typeface="Calibri" pitchFamily="34" charset="-122"/>
+                <a:cs typeface="Calibri" pitchFamily="34" charset="-120"/>
+              </a:rPr>
+              <a:t>ESTADOS EXAURIDOS</a:t>
+            </a:r>
+            <a:endParaRPr lang="en-US" sz="1100" dirty="0"/>
+          </a:p>
+        </p:txBody>
+      </p:sp>
+      <p:sp>
+        <p:nvSpPr>
+          <p:cNvPr id="12" name="Text 8"/>
+          <p:cNvSpPr txBox="1"/>
+          <p:nvPr/>
+        </p:nvSpPr>
+        <p:spPr>
+          <a:xfrm>
+            <a:off x="9500616" y="4315968"/>
+            <a:ext cx="2121408" cy="685800"/>
+          </a:xfrm>
+          <a:prstGeom prst="rect">
+            <a:avLst/>
+          </a:prstGeom>
+          <a:noFill/>
+          <a:ln/>
+        </p:spPr>
+        <p:txBody>
+          <a:bodyPr wrap="square" rtlCol="0" anchor="t"/>
+          <a:lstStyle/>
+          <a:p>
+            <a:pPr indent="0" marL="0">
+              <a:buNone/>
+            </a:pPr>
+            <a:r>
+              <a:rPr lang="en-US" sz="3200" b="1" dirty="0">
+                <a:solidFill>
+                  <a:srgbClr val="33291F"/>
+                </a:solidFill>
+                <a:latin typeface="Cambria" pitchFamily="34" charset="0"/>
+                <a:ea typeface="Cambria" pitchFamily="34" charset="-122"/>
+                <a:cs typeface="Cambria" pitchFamily="34" charset="-120"/>
+              </a:rPr>
+              <a:t>0,03s</a:t>
+            </a:r>
+            <a:endParaRPr lang="en-US" sz="3200" dirty="0"/>
+          </a:p>
+        </p:txBody>
+      </p:sp>
+      <p:sp>
+        <p:nvSpPr>
+          <p:cNvPr id="13" name="Text 9"/>
+          <p:cNvSpPr txBox="1"/>
+          <p:nvPr/>
+        </p:nvSpPr>
+        <p:spPr>
+          <a:xfrm>
+            <a:off x="9500616" y="4974336"/>
+            <a:ext cx="2121408" cy="548640"/>
+          </a:xfrm>
+          <a:prstGeom prst="rect">
+            <a:avLst/>
+          </a:prstGeom>
+          <a:noFill/>
+          <a:ln/>
+        </p:spPr>
+        <p:txBody>
+          <a:bodyPr wrap="square" rtlCol="0" anchor="ctr"/>
+          <a:lstStyle/>
+          <a:p>
+            <a:pPr indent="0" marL="0">
+              <a:buNone/>
+            </a:pPr>
+            <a:r>
+              <a:rPr lang="en-US" sz="1100" spc="70" kern="0" dirty="0">
+                <a:solidFill>
+                  <a:srgbClr val="8A7A67"/>
+                </a:solidFill>
+                <a:latin typeface="Calibri" pitchFamily="34" charset="0"/>
+                <a:ea typeface="Calibri" pitchFamily="34" charset="-122"/>
+                <a:cs typeface="Calibri" pitchFamily="34" charset="-120"/>
+              </a:rPr>
+              <a:t>PARA PROVAR</a:t>
+            </a:r>
+            <a:endParaRPr lang="en-US" sz="1100" dirty="0"/>
+          </a:p>
+        </p:txBody>
+      </p:sp>
+      <p:sp>
+        <p:nvSpPr>
+          <p:cNvPr id="14" name="Shape 10"/>
+          <p:cNvSpPr/>
+          <p:nvPr/>
+        </p:nvSpPr>
+        <p:spPr>
+          <a:xfrm>
+            <a:off x="7379208" y="5394960"/>
+            <a:ext cx="4242816" cy="0"/>
+          </a:xfrm>
+          <a:prstGeom prst="line">
+            <a:avLst/>
+          </a:prstGeom>
+          <a:noFill/>
+          <a:ln w="12700">
+            <a:solidFill>
+              <a:srgbClr val="E6DCCB"/>
+            </a:solidFill>
+            <a:prstDash val="solid"/>
+          </a:ln>
+        </p:spPr>
+      </p:sp>
+      <p:sp>
+        <p:nvSpPr>
+          <p:cNvPr id="15" name="Text 11"/>
+          <p:cNvSpPr txBox="1"/>
+          <p:nvPr/>
+        </p:nvSpPr>
+        <p:spPr>
+          <a:xfrm>
+            <a:off x="7379208" y="5522976"/>
+            <a:ext cx="4242816" cy="1005840"/>
+          </a:xfrm>
+          <a:prstGeom prst="rect">
+            <a:avLst/>
+          </a:prstGeom>
+          <a:noFill/>
+          <a:ln/>
+        </p:spPr>
+        <p:txBody>
+          <a:bodyPr wrap="square" rtlCol="0" anchor="t"/>
+          <a:lstStyle/>
+          <a:p>
+            <a:pPr indent="0" marL="0">
+              <a:lnSpc>
+                <a:spcPct val="112000"/>
+              </a:lnSpc>
+              <a:buNone/>
+            </a:pPr>
+            <a:r>
+              <a:rPr lang="en-US" sz="1700" dirty="0">
+                <a:solidFill>
+                  <a:srgbClr val="33291F"/>
+                </a:solidFill>
+                <a:latin typeface="Cambria" pitchFamily="34" charset="0"/>
+                <a:ea typeface="Cambria" pitchFamily="34" charset="-122"/>
+                <a:cs typeface="Cambria" pitchFamily="34" charset="-120"/>
+              </a:rPr>
+              <a:t>O planejamento não disse que não encontrou: ele exauriu o espaço e </a:t>
+            </a:r>
+            <a:pPr indent="0" marL="0">
+              <a:lnSpc>
+                <a:spcPct val="112000"/>
+              </a:lnSpc>
+              <a:buNone/>
+            </a:pPr>
+            <a:r>
+              <a:rPr lang="en-US" sz="1700" b="1" dirty="0">
+                <a:solidFill>
+                  <a:srgbClr val="33291F"/>
+                </a:solidFill>
+                <a:latin typeface="Cambria" pitchFamily="34" charset="0"/>
+                <a:ea typeface="Cambria" pitchFamily="34" charset="-122"/>
+                <a:cs typeface="Cambria" pitchFamily="34" charset="-120"/>
+              </a:rPr>
+              <a:t>demonstrou que não existe</a:t>
+            </a:r>
+            <a:pPr indent="0" marL="0">
+              <a:lnSpc>
+                <a:spcPct val="112000"/>
+              </a:lnSpc>
+              <a:buNone/>
+            </a:pPr>
+            <a:r>
+              <a:rPr lang="en-US" sz="1700" dirty="0">
+                <a:solidFill>
+                  <a:srgbClr val="33291F"/>
+                </a:solidFill>
+                <a:latin typeface="Cambria" pitchFamily="34" charset="0"/>
+                <a:ea typeface="Cambria" pitchFamily="34" charset="-122"/>
+                <a:cs typeface="Cambria" pitchFamily="34" charset="-120"/>
+              </a:rPr>
+              <a:t>.</a:t>
+            </a:r>
+            <a:endParaRPr lang="en-US" sz="1700" dirty="0"/>
+          </a:p>
+        </p:txBody>
+      </p:sp>
+    </p:spTree>
+  </p:cSld>
+  <p:clrMapOvr>
+    <a:masterClrMapping/>
+  </p:clrMapOvr>
+</p:sld>
+</file>
+
+<file path=ppt/slides/slide17.xml><?xml version="1.0" encoding="utf-8"?>
+<p:sld xmlns:a="http://schemas.openxmlformats.org/drawingml/2006/main" xmlns:r="http://schemas.openxmlformats.org/officeDocument/2006/relationships" xmlns:p="http://schemas.openxmlformats.org/presentationml/2006/main">
+  <p:cSld name="Slide 17">
+    <p:bg>
+      <p:bgPr>
+        <a:blipFill dpi="0" rotWithShape="1">
+          <a:blip r:embed="rId1">
+            <a:lum/>
+          </a:blip>
+          <a:srcRect/>
+          <a:stretch>
+            <a:fillRect/>
+          </a:stretch>
+        </a:blipFill>
+        <a:effectLst/>
+      </p:bgPr>
+    </p:bg>
+    <p:spTree>
+      <p:nvGrpSpPr>
+        <p:cNvPr id="1" name=""/>
+        <p:cNvGrpSpPr/>
+        <p:nvPr/>
+      </p:nvGrpSpPr>
+      <p:grpSpPr>
+        <a:xfrm>
+          <a:off x="0" y="0"/>
+          <a:ext cx="0" cy="0"/>
+          <a:chOff x="0" y="0"/>
+          <a:chExt cx="0" cy="0"/>
+        </a:xfrm>
+      </p:grpSpPr>
+      <p:sp>
+        <p:nvSpPr>
+          <p:cNvPr id="3" name="Text 0"/>
+          <p:cNvSpPr txBox="1"/>
+          <p:nvPr/>
+        </p:nvSpPr>
+        <p:spPr>
+          <a:xfrm>
+            <a:off x="566928" y="347472"/>
+            <a:ext cx="11055096" cy="292608"/>
+          </a:xfrm>
+          <a:prstGeom prst="rect">
+            <a:avLst/>
+          </a:prstGeom>
+          <a:noFill/>
+          <a:ln/>
+        </p:spPr>
+        <p:txBody>
+          <a:bodyPr wrap="square" rtlCol="0" anchor="ctr"/>
+          <a:lstStyle/>
+          <a:p>
+            <a:pPr indent="0" marL="0">
+              <a:buNone/>
+            </a:pPr>
+            <a:r>
+              <a:rPr lang="en-US" sz="1300" b="1" spc="160" kern="0" dirty="0">
+                <a:solidFill>
+                  <a:srgbClr val="B35C38"/>
+                </a:solidFill>
+                <a:latin typeface="Calibri" pitchFamily="34" charset="0"/>
+                <a:ea typeface="Calibri" pitchFamily="34" charset="-122"/>
+                <a:cs typeface="Calibri" pitchFamily="34" charset="-120"/>
+              </a:rPr>
+              <a:t>DEMONSTRAÇÃO · PASSO 2, DE NOVO</a:t>
+            </a:r>
+            <a:endParaRPr lang="en-US" sz="1300" dirty="0"/>
+          </a:p>
+        </p:txBody>
+      </p:sp>
+      <p:sp>
+        <p:nvSpPr>
+          <p:cNvPr id="4" name="Text 1"/>
+          <p:cNvSpPr txBox="1"/>
+          <p:nvPr/>
+        </p:nvSpPr>
+        <p:spPr>
+          <a:xfrm>
+            <a:off x="566928" y="658368"/>
+            <a:ext cx="11055096" cy="731520"/>
+          </a:xfrm>
+          <a:prstGeom prst="rect">
+            <a:avLst/>
+          </a:prstGeom>
+          <a:noFill/>
+          <a:ln/>
+        </p:spPr>
+        <p:txBody>
+          <a:bodyPr wrap="square" rtlCol="0" anchor="t"/>
+          <a:lstStyle/>
+          <a:p>
+            <a:pPr indent="0" marL="0">
+              <a:lnSpc>
+                <a:spcPct val="100000"/>
+              </a:lnSpc>
+              <a:buNone/>
+            </a:pPr>
+            <a:r>
+              <a:rPr lang="en-US" sz="3400" b="1" dirty="0">
+                <a:solidFill>
+                  <a:srgbClr val="33291F"/>
+                </a:solidFill>
+                <a:latin typeface="Cambria" pitchFamily="34" charset="0"/>
+                <a:ea typeface="Cambria" pitchFamily="34" charset="-122"/>
+                <a:cs typeface="Cambria" pitchFamily="34" charset="-120"/>
+              </a:rPr>
+              <a:t>Outra rota, exatamente a mesma distância</a:t>
+            </a:r>
+            <a:endParaRPr lang="en-US" sz="3400" dirty="0"/>
+          </a:p>
+        </p:txBody>
+      </p:sp>
+      <p:sp>
+        <p:nvSpPr>
+          <p:cNvPr id="5" name="Shape 2"/>
+          <p:cNvSpPr/>
+          <p:nvPr/>
+        </p:nvSpPr>
+        <p:spPr>
+          <a:xfrm>
+            <a:off x="512064" y="1517904"/>
+            <a:ext cx="6510528" cy="4773168"/>
+          </a:xfrm>
+          <a:prstGeom prst="roundRect">
+            <a:avLst>
+              <a:gd name="adj" fmla="val 1916"/>
+            </a:avLst>
+          </a:prstGeom>
+          <a:solidFill>
+            <a:srgbClr val="FFFDF8"/>
+          </a:solidFill>
+          <a:ln w="12700">
+            <a:solidFill>
+              <a:srgbClr val="E6DCCB"/>
+            </a:solidFill>
+            <a:prstDash val="solid"/>
+          </a:ln>
+        </p:spPr>
+      </p:sp>
+      <p:pic>
+        <p:nvPicPr>
+          <p:cNvPr id="6" name="Image 0" descr="apresentacao\3\passos\passo4.jpg">    </p:cNvPr>
+          <p:cNvPicPr>
+            <a:picLocks noChangeAspect="1"/>
+          </p:cNvPicPr>
+          <p:nvPr/>
+        </p:nvPicPr>
+        <p:blipFill>
+          <a:blip r:embed="rId2"/>
+          <a:stretch>
+            <a:fillRect/>
+          </a:stretch>
+        </p:blipFill>
+        <p:spPr>
+          <a:xfrm>
+            <a:off x="566928" y="1572768"/>
+            <a:ext cx="6400800" cy="4663440"/>
+          </a:xfrm>
+          <a:prstGeom prst="rect">
+            <a:avLst/>
+          </a:prstGeom>
+        </p:spPr>
+      </p:pic>
+      <p:sp>
+        <p:nvSpPr>
+          <p:cNvPr id="7" name="Text 3"/>
+          <p:cNvSpPr txBox="1"/>
+          <p:nvPr/>
+        </p:nvSpPr>
+        <p:spPr>
+          <a:xfrm>
+            <a:off x="7379208" y="1691640"/>
+            <a:ext cx="4242816" cy="2286000"/>
+          </a:xfrm>
+          <a:prstGeom prst="rect">
+            <a:avLst/>
+          </a:prstGeom>
+          <a:noFill/>
+          <a:ln/>
+        </p:spPr>
+        <p:txBody>
+          <a:bodyPr wrap="square" rtlCol="0" anchor="t"/>
+          <a:lstStyle/>
+          <a:p>
+            <a:pPr indent="0" marL="0">
+              <a:lnSpc>
+                <a:spcPct val="114000"/>
+              </a:lnSpc>
+              <a:buNone/>
+            </a:pPr>
+            <a:r>
+              <a:rPr lang="en-US" sz="1700" dirty="0">
+                <a:solidFill>
+                  <a:srgbClr val="5C4F41"/>
+                </a:solidFill>
+                <a:latin typeface="Calibri" pitchFamily="34" charset="0"/>
+                <a:ea typeface="Calibri" pitchFamily="34" charset="-122"/>
+                <a:cs typeface="Calibri" pitchFamily="34" charset="-120"/>
+              </a:rPr>
+              <a:t>A camada geométrica é chamada outra vez e devolve outra ordem. É a </a:t>
+            </a:r>
+            <a:pPr indent="0" marL="0">
+              <a:lnSpc>
+                <a:spcPct val="114000"/>
+              </a:lnSpc>
+              <a:buNone/>
+            </a:pPr>
+            <a:r>
+              <a:rPr lang="en-US" sz="1700" b="1" dirty="0">
+                <a:solidFill>
+                  <a:srgbClr val="5C4F41"/>
+                </a:solidFill>
+                <a:latin typeface="Calibri" pitchFamily="34" charset="0"/>
+                <a:ea typeface="Calibri" pitchFamily="34" charset="-122"/>
+                <a:cs typeface="Calibri" pitchFamily="34" charset="-120"/>
+              </a:rPr>
+              <a:t>mesma volta percorrida ao contrário</a:t>
+            </a:r>
+            <a:pPr indent="0" marL="0">
+              <a:lnSpc>
+                <a:spcPct val="114000"/>
+              </a:lnSpc>
+              <a:buNone/>
+            </a:pPr>
+            <a:r>
+              <a:rPr lang="en-US" sz="1700" dirty="0">
+                <a:solidFill>
+                  <a:srgbClr val="5C4F41"/>
+                </a:solidFill>
+                <a:latin typeface="Calibri" pitchFamily="34" charset="0"/>
+                <a:ea typeface="Calibri" pitchFamily="34" charset="-122"/>
+                <a:cs typeface="Calibri" pitchFamily="34" charset="-120"/>
+              </a:rPr>
+              <a:t>, e por isso custa exatamente os mesmos 94 minutos de caminhada.</a:t>
+            </a:r>
+            <a:endParaRPr lang="en-US" sz="1700" dirty="0"/>
+          </a:p>
+        </p:txBody>
+      </p:sp>
+      <p:sp>
+        <p:nvSpPr>
+          <p:cNvPr id="8" name="Text 4"/>
+          <p:cNvSpPr txBox="1"/>
+          <p:nvPr/>
+        </p:nvSpPr>
+        <p:spPr>
+          <a:xfrm>
+            <a:off x="7379208" y="4315968"/>
+            <a:ext cx="2121408" cy="685800"/>
+          </a:xfrm>
+          <a:prstGeom prst="rect">
+            <a:avLst/>
+          </a:prstGeom>
+          <a:noFill/>
+          <a:ln/>
+        </p:spPr>
+        <p:txBody>
+          <a:bodyPr wrap="square" rtlCol="0" anchor="t"/>
+          <a:lstStyle/>
+          <a:p>
+            <a:pPr indent="0" marL="0">
+              <a:buNone/>
+            </a:pPr>
+            <a:r>
+              <a:rPr lang="en-US" sz="3200" b="1" dirty="0">
+                <a:solidFill>
+                  <a:srgbClr val="33291F"/>
+                </a:solidFill>
+                <a:latin typeface="Cambria" pitchFamily="34" charset="0"/>
+                <a:ea typeface="Cambria" pitchFamily="34" charset="-122"/>
+                <a:cs typeface="Cambria" pitchFamily="34" charset="-120"/>
+              </a:rPr>
+              <a:t>94</a:t>
+            </a:r>
+            <a:endParaRPr lang="en-US" sz="3200" dirty="0"/>
+          </a:p>
+        </p:txBody>
+      </p:sp>
+      <p:sp>
+        <p:nvSpPr>
+          <p:cNvPr id="9" name="Text 5"/>
+          <p:cNvSpPr txBox="1"/>
+          <p:nvPr/>
+        </p:nvSpPr>
+        <p:spPr>
+          <a:xfrm>
+            <a:off x="7379208" y="4974336"/>
+            <a:ext cx="2121408" cy="548640"/>
+          </a:xfrm>
+          <a:prstGeom prst="rect">
+            <a:avLst/>
+          </a:prstGeom>
+          <a:noFill/>
+          <a:ln/>
+        </p:spPr>
+        <p:txBody>
+          <a:bodyPr wrap="square" rtlCol="0" anchor="ctr"/>
+          <a:lstStyle/>
+          <a:p>
+            <a:pPr indent="0" marL="0">
+              <a:buNone/>
+            </a:pPr>
+            <a:r>
+              <a:rPr lang="en-US" sz="1100" spc="70" kern="0" dirty="0">
+                <a:solidFill>
+                  <a:srgbClr val="8A7A67"/>
+                </a:solidFill>
+                <a:latin typeface="Calibri" pitchFamily="34" charset="0"/>
+                <a:ea typeface="Calibri" pitchFamily="34" charset="-122"/>
+                <a:cs typeface="Calibri" pitchFamily="34" charset="-120"/>
+              </a:rPr>
+              <a:t>MIN DE CAMINHADA</a:t>
+            </a:r>
+            <a:endParaRPr lang="en-US" sz="1100" dirty="0"/>
+          </a:p>
+        </p:txBody>
+      </p:sp>
+      <p:sp>
+        <p:nvSpPr>
+          <p:cNvPr id="10" name="Text 6"/>
+          <p:cNvSpPr txBox="1"/>
+          <p:nvPr/>
+        </p:nvSpPr>
+        <p:spPr>
+          <a:xfrm>
+            <a:off x="9500616" y="4315968"/>
+            <a:ext cx="2121408" cy="685800"/>
+          </a:xfrm>
+          <a:prstGeom prst="rect">
+            <a:avLst/>
+          </a:prstGeom>
+          <a:noFill/>
+          <a:ln/>
+        </p:spPr>
+        <p:txBody>
+          <a:bodyPr wrap="square" rtlCol="0" anchor="t"/>
+          <a:lstStyle/>
+          <a:p>
+            <a:pPr indent="0" marL="0">
+              <a:buNone/>
+            </a:pPr>
+            <a:r>
+              <a:rPr lang="en-US" sz="3200" b="1" dirty="0">
+                <a:solidFill>
+                  <a:srgbClr val="33291F"/>
+                </a:solidFill>
+                <a:latin typeface="Cambria" pitchFamily="34" charset="0"/>
+                <a:ea typeface="Cambria" pitchFamily="34" charset="-122"/>
+                <a:cs typeface="Cambria" pitchFamily="34" charset="-120"/>
+              </a:rPr>
+              <a:t>0</a:t>
+            </a:r>
+            <a:endParaRPr lang="en-US" sz="3200" dirty="0"/>
+          </a:p>
+        </p:txBody>
+      </p:sp>
+      <p:sp>
+        <p:nvSpPr>
+          <p:cNvPr id="11" name="Text 7"/>
+          <p:cNvSpPr txBox="1"/>
+          <p:nvPr/>
+        </p:nvSpPr>
+        <p:spPr>
+          <a:xfrm>
+            <a:off x="9500616" y="4974336"/>
+            <a:ext cx="2121408" cy="548640"/>
+          </a:xfrm>
+          <a:prstGeom prst="rect">
+            <a:avLst/>
+          </a:prstGeom>
+          <a:noFill/>
+          <a:ln/>
+        </p:spPr>
+        <p:txBody>
+          <a:bodyPr wrap="square" rtlCol="0" anchor="ctr"/>
+          <a:lstStyle/>
+          <a:p>
+            <a:pPr indent="0" marL="0">
+              <a:buNone/>
+            </a:pPr>
+            <a:r>
+              <a:rPr lang="en-US" sz="1100" spc="70" kern="0" dirty="0">
+                <a:solidFill>
+                  <a:srgbClr val="8A7A67"/>
+                </a:solidFill>
+                <a:latin typeface="Calibri" pitchFamily="34" charset="0"/>
+                <a:ea typeface="Calibri" pitchFamily="34" charset="-122"/>
+                <a:cs typeface="Calibri" pitchFamily="34" charset="-120"/>
+              </a:rPr>
+              <a:t>MIN A MAIS</a:t>
+            </a:r>
+            <a:endParaRPr lang="en-US" sz="1100" dirty="0"/>
+          </a:p>
+        </p:txBody>
+      </p:sp>
+      <p:sp>
+        <p:nvSpPr>
+          <p:cNvPr id="12" name="Shape 8"/>
+          <p:cNvSpPr/>
+          <p:nvPr/>
+        </p:nvSpPr>
+        <p:spPr>
+          <a:xfrm>
+            <a:off x="7379208" y="5394960"/>
+            <a:ext cx="4242816" cy="0"/>
+          </a:xfrm>
+          <a:prstGeom prst="line">
+            <a:avLst/>
+          </a:prstGeom>
+          <a:noFill/>
+          <a:ln w="12700">
+            <a:solidFill>
+              <a:srgbClr val="E6DCCB"/>
+            </a:solidFill>
+            <a:prstDash val="solid"/>
+          </a:ln>
+        </p:spPr>
+      </p:sp>
+      <p:sp>
+        <p:nvSpPr>
+          <p:cNvPr id="13" name="Text 9"/>
+          <p:cNvSpPr txBox="1"/>
+          <p:nvPr/>
+        </p:nvSpPr>
+        <p:spPr>
+          <a:xfrm>
+            <a:off x="7379208" y="5522976"/>
+            <a:ext cx="4242816" cy="1005840"/>
+          </a:xfrm>
+          <a:prstGeom prst="rect">
+            <a:avLst/>
+          </a:prstGeom>
+          <a:noFill/>
+          <a:ln/>
+        </p:spPr>
+        <p:txBody>
+          <a:bodyPr wrap="square" rtlCol="0" anchor="t"/>
+          <a:lstStyle/>
+          <a:p>
+            <a:pPr indent="0" marL="0">
+              <a:lnSpc>
+                <a:spcPct val="112000"/>
+              </a:lnSpc>
+              <a:buNone/>
+            </a:pPr>
+            <a:r>
+              <a:rPr lang="en-US" sz="1700" dirty="0">
+                <a:solidFill>
+                  <a:srgbClr val="33291F"/>
+                </a:solidFill>
+                <a:latin typeface="Cambria" pitchFamily="34" charset="0"/>
+                <a:ea typeface="Cambria" pitchFamily="34" charset="-122"/>
+                <a:cs typeface="Cambria" pitchFamily="34" charset="-120"/>
+              </a:rPr>
+              <a:t>O que separa uma rota válida de uma inválida aqui não é o comprimento, é a ordem.</a:t>
+            </a:r>
+            <a:endParaRPr lang="en-US" sz="1700" dirty="0"/>
+          </a:p>
+        </p:txBody>
+      </p:sp>
+    </p:spTree>
+  </p:cSld>
+  <p:clrMapOvr>
+    <a:masterClrMapping/>
+  </p:clrMapOvr>
+</p:sld>
+</file>
+
+<file path=ppt/slides/slide18.xml><?xml version="1.0" encoding="utf-8"?>
+<p:sld xmlns:a="http://schemas.openxmlformats.org/drawingml/2006/main" xmlns:r="http://schemas.openxmlformats.org/officeDocument/2006/relationships" xmlns:p="http://schemas.openxmlformats.org/presentationml/2006/main">
+  <p:cSld name="Slide 18">
+    <p:bg>
+      <p:bgPr>
+        <a:blipFill dpi="0" rotWithShape="1">
+          <a:blip r:embed="rId1">
+            <a:lum/>
+          </a:blip>
+          <a:srcRect/>
+          <a:stretch>
+            <a:fillRect/>
+          </a:stretch>
+        </a:blipFill>
+        <a:effectLst/>
+      </p:bgPr>
+    </p:bg>
+    <p:spTree>
+      <p:nvGrpSpPr>
+        <p:cNvPr id="1" name=""/>
+        <p:cNvGrpSpPr/>
+        <p:nvPr/>
+      </p:nvGrpSpPr>
+      <p:grpSpPr>
+        <a:xfrm>
+          <a:off x="0" y="0"/>
+          <a:ext cx="0" cy="0"/>
+          <a:chOff x="0" y="0"/>
+          <a:chExt cx="0" cy="0"/>
+        </a:xfrm>
+      </p:grpSpPr>
+      <p:sp>
+        <p:nvSpPr>
+          <p:cNvPr id="3" name="Text 0"/>
+          <p:cNvSpPr txBox="1"/>
+          <p:nvPr/>
+        </p:nvSpPr>
+        <p:spPr>
+          <a:xfrm>
+            <a:off x="566928" y="347472"/>
+            <a:ext cx="11055096" cy="292608"/>
+          </a:xfrm>
+          <a:prstGeom prst="rect">
+            <a:avLst/>
+          </a:prstGeom>
+          <a:noFill/>
+          <a:ln/>
+        </p:spPr>
+        <p:txBody>
+          <a:bodyPr wrap="square" rtlCol="0" anchor="ctr"/>
+          <a:lstStyle/>
+          <a:p>
+            <a:pPr indent="0" marL="0">
+              <a:buNone/>
+            </a:pPr>
+            <a:r>
+              <a:rPr lang="en-US" sz="1300" b="1" spc="160" kern="0" dirty="0">
+                <a:solidFill>
+                  <a:srgbClr val="B35C38"/>
+                </a:solidFill>
+                <a:latin typeface="Calibri" pitchFamily="34" charset="0"/>
+                <a:ea typeface="Calibri" pitchFamily="34" charset="-122"/>
+                <a:cs typeface="Calibri" pitchFamily="34" charset="-120"/>
+              </a:rPr>
+              <a:t>DEMONSTRAÇÃO · PASSO 3</a:t>
+            </a:r>
+            <a:endParaRPr lang="en-US" sz="1300" dirty="0"/>
+          </a:p>
+        </p:txBody>
+      </p:sp>
+      <p:sp>
+        <p:nvSpPr>
+          <p:cNvPr id="4" name="Text 1"/>
+          <p:cNvSpPr txBox="1"/>
+          <p:nvPr/>
+        </p:nvSpPr>
+        <p:spPr>
+          <a:xfrm>
+            <a:off x="566928" y="658368"/>
+            <a:ext cx="11055096" cy="731520"/>
+          </a:xfrm>
+          <a:prstGeom prst="rect">
+            <a:avLst/>
+          </a:prstGeom>
+          <a:noFill/>
+          <a:ln/>
+        </p:spPr>
+        <p:txBody>
+          <a:bodyPr wrap="square" rtlCol="0" anchor="t"/>
+          <a:lstStyle/>
+          <a:p>
+            <a:pPr indent="0" marL="0">
+              <a:lnSpc>
+                <a:spcPct val="100000"/>
+              </a:lnSpc>
+              <a:buNone/>
+            </a:pPr>
+            <a:r>
+              <a:rPr lang="en-US" sz="3400" b="1" dirty="0">
+                <a:solidFill>
+                  <a:srgbClr val="33291F"/>
+                </a:solidFill>
+                <a:latin typeface="Cambria" pitchFamily="34" charset="0"/>
+                <a:ea typeface="Cambria" pitchFamily="34" charset="-122"/>
+                <a:cs typeface="Cambria" pitchFamily="34" charset="-120"/>
+              </a:rPr>
+              <a:t>O protocolo cabe nesta rota</a:t>
+            </a:r>
+            <a:endParaRPr lang="en-US" sz="3400" dirty="0"/>
+          </a:p>
+        </p:txBody>
+      </p:sp>
+      <p:sp>
+        <p:nvSpPr>
+          <p:cNvPr id="5" name="Shape 2"/>
+          <p:cNvSpPr/>
+          <p:nvPr/>
+        </p:nvSpPr>
+        <p:spPr>
+          <a:xfrm>
+            <a:off x="512064" y="1517904"/>
+            <a:ext cx="6510528" cy="4773168"/>
+          </a:xfrm>
+          <a:prstGeom prst="roundRect">
+            <a:avLst>
+              <a:gd name="adj" fmla="val 1916"/>
+            </a:avLst>
+          </a:prstGeom>
+          <a:solidFill>
+            <a:srgbClr val="FFFDF8"/>
+          </a:solidFill>
+          <a:ln w="12700">
+            <a:solidFill>
+              <a:srgbClr val="E6DCCB"/>
+            </a:solidFill>
+            <a:prstDash val="solid"/>
+          </a:ln>
+        </p:spPr>
+      </p:sp>
+      <p:pic>
+        <p:nvPicPr>
+          <p:cNvPr id="6" name="Image 0" descr="apresentacao\3\passos\passo5.jpg">    </p:cNvPr>
+          <p:cNvPicPr>
+            <a:picLocks noChangeAspect="1"/>
+          </p:cNvPicPr>
+          <p:nvPr/>
+        </p:nvPicPr>
+        <p:blipFill>
+          <a:blip r:embed="rId2"/>
+          <a:stretch>
+            <a:fillRect/>
+          </a:stretch>
+        </p:blipFill>
+        <p:spPr>
+          <a:xfrm>
+            <a:off x="566928" y="1572768"/>
+            <a:ext cx="6400800" cy="4663440"/>
+          </a:xfrm>
+          <a:prstGeom prst="rect">
+            <a:avLst/>
+          </a:prstGeom>
+        </p:spPr>
+      </p:pic>
+      <p:sp>
+        <p:nvSpPr>
+          <p:cNvPr id="7" name="Shape 3"/>
+          <p:cNvSpPr/>
+          <p:nvPr/>
+        </p:nvSpPr>
+        <p:spPr>
+          <a:xfrm>
+            <a:off x="7379208" y="1691640"/>
+            <a:ext cx="3200400" cy="384048"/>
+          </a:xfrm>
+          <a:prstGeom prst="roundRect">
+            <a:avLst>
+              <a:gd name="adj" fmla="val 119048"/>
             </a:avLst>
           </a:prstGeom>
           <a:solidFill>
@@ -4784,14 +7035,53 @@
       </p:sp>
       <p:sp>
         <p:nvSpPr>
-          <p:cNvPr id="6" name="Text 3"/>
-          <p:cNvSpPr txBox="1"/>
-          <p:nvPr/>
-        </p:nvSpPr>
-        <p:spPr>
-          <a:xfrm>
-            <a:off x="877824" y="2011680"/>
-            <a:ext cx="10433304" cy="1417320"/>
+          <p:cNvPr id="8" name="Text 4"/>
+          <p:cNvSpPr txBox="1"/>
+          <p:nvPr/>
+        </p:nvSpPr>
+        <p:spPr>
+          <a:xfrm>
+            <a:off x="7379208" y="1691640"/>
+            <a:ext cx="3200400" cy="384048"/>
+          </a:xfrm>
+          <a:prstGeom prst="rect">
+            <a:avLst/>
+          </a:prstGeom>
+          <a:noFill/>
+          <a:ln/>
+        </p:spPr>
+        <p:txBody>
+          <a:bodyPr wrap="square" rtlCol="0" anchor="ctr"/>
+          <a:lstStyle/>
+          <a:p>
+            <a:pPr algn="ctr" indent="0" marL="0">
+              <a:buNone/>
+            </a:pPr>
+            <a:r>
+              <a:rPr lang="en-US" sz="1300" b="1" dirty="0">
+                <a:solidFill>
+                  <a:srgbClr val="4A6B5B"/>
+                </a:solidFill>
+                <a:latin typeface="Calibri" pitchFamily="34" charset="0"/>
+                <a:ea typeface="Calibri" pitchFamily="34" charset="-122"/>
+                <a:cs typeface="Calibri" pitchFamily="34" charset="-120"/>
+              </a:rPr>
+              <a:t>rota válida sob o protocolo</a:t>
+            </a:r>
+            <a:endParaRPr lang="en-US" sz="1300" dirty="0"/>
+          </a:p>
+        </p:txBody>
+      </p:sp>
+      <p:sp>
+        <p:nvSpPr>
+          <p:cNvPr id="9" name="Text 5"/>
+          <p:cNvSpPr txBox="1"/>
+          <p:nvPr/>
+        </p:nvSpPr>
+        <p:spPr>
+          <a:xfrm>
+            <a:off x="7379208" y="2258568"/>
+            <a:ext cx="4242816" cy="2286000"/>
           </a:xfrm>
           <a:prstGeom prst="rect">
             <a:avLst/>
@@ -4805,12 +7095,51 @@
           <a:p>
             <a:pPr indent="0" marL="0">
               <a:lnSpc>
-                <a:spcPct val="112000"/>
-              </a:lnSpc>
-              <a:buNone/>
-            </a:pPr>
-            <a:r>
-              <a:rPr lang="en-US" sz="2500" i="1" dirty="0">
+                <a:spcPct val="114000"/>
+              </a:lnSpc>
+              <a:buNone/>
+            </a:pPr>
+            <a:r>
+              <a:rPr lang="en-US" sz="1700" dirty="0">
+                <a:solidFill>
+                  <a:srgbClr val="5C4F41"/>
+                </a:solidFill>
+                <a:latin typeface="Calibri" pitchFamily="34" charset="0"/>
+                <a:ea typeface="Calibri" pitchFamily="34" charset="-122"/>
+                <a:cs typeface="Calibri" pitchFamily="34" charset="-120"/>
+              </a:rPr>
+              <a:t>O planejamento encontrou uma sequência de 51 ações, de custo 266 minutos, que cumpre as condições do art. 3º § 4º em todas as paradas: curso técnico, equipamento, supervisão ativa, insumo disponível e encaminhamento quando o procedimento o exige.</a:t>
+            </a:r>
+            <a:endParaRPr lang="en-US" sz="1700" dirty="0"/>
+          </a:p>
+        </p:txBody>
+      </p:sp>
+      <p:sp>
+        <p:nvSpPr>
+          <p:cNvPr id="10" name="Text 6"/>
+          <p:cNvSpPr txBox="1"/>
+          <p:nvPr/>
+        </p:nvSpPr>
+        <p:spPr>
+          <a:xfrm>
+            <a:off x="7379208" y="4315968"/>
+            <a:ext cx="2121408" cy="685800"/>
+          </a:xfrm>
+          <a:prstGeom prst="rect">
+            <a:avLst/>
+          </a:prstGeom>
+          <a:noFill/>
+          <a:ln/>
+        </p:spPr>
+        <p:txBody>
+          <a:bodyPr wrap="square" rtlCol="0" anchor="t"/>
+          <a:lstStyle/>
+          <a:p>
+            <a:pPr indent="0" marL="0">
+              <a:buNone/>
+            </a:pPr>
+            <a:r>
+              <a:rPr lang="en-US" sz="3200" b="1" dirty="0">
                 <a:solidFill>
                   <a:srgbClr val="33291F"/>
                 </a:solidFill>
@@ -4818,26 +7147,328 @@
                 <a:ea typeface="Cambria" pitchFamily="34" charset="-122"/>
                 <a:cs typeface="Cambria" pitchFamily="34" charset="-120"/>
               </a:rPr>
-              <a:t>“Manter a norma como especificação declarativa preserva a corretude do sistema diante de regras novas, a um custo de busca que ainda cabe num turno real.”</a:t>
-            </a:r>
-            <a:endParaRPr lang="en-US" sz="2500" dirty="0"/>
-          </a:p>
-        </p:txBody>
-      </p:sp>
-      <p:sp>
-        <p:nvSpPr>
-          <p:cNvPr id="7" name="Shape 4"/>
+              <a:t>51</a:t>
+            </a:r>
+            <a:endParaRPr lang="en-US" sz="3200" dirty="0"/>
+          </a:p>
+        </p:txBody>
+      </p:sp>
+      <p:sp>
+        <p:nvSpPr>
+          <p:cNvPr id="11" name="Text 7"/>
+          <p:cNvSpPr txBox="1"/>
+          <p:nvPr/>
+        </p:nvSpPr>
+        <p:spPr>
+          <a:xfrm>
+            <a:off x="7379208" y="4974336"/>
+            <a:ext cx="2121408" cy="548640"/>
+          </a:xfrm>
+          <a:prstGeom prst="rect">
+            <a:avLst/>
+          </a:prstGeom>
+          <a:noFill/>
+          <a:ln/>
+        </p:spPr>
+        <p:txBody>
+          <a:bodyPr wrap="square" rtlCol="0" anchor="ctr"/>
+          <a:lstStyle/>
+          <a:p>
+            <a:pPr indent="0" marL="0">
+              <a:buNone/>
+            </a:pPr>
+            <a:r>
+              <a:rPr lang="en-US" sz="1100" spc="70" kern="0" dirty="0">
+                <a:solidFill>
+                  <a:srgbClr val="8A7A67"/>
+                </a:solidFill>
+                <a:latin typeface="Calibri" pitchFamily="34" charset="0"/>
+                <a:ea typeface="Calibri" pitchFamily="34" charset="-122"/>
+                <a:cs typeface="Calibri" pitchFamily="34" charset="-120"/>
+              </a:rPr>
+              <a:t>AÇÕES</a:t>
+            </a:r>
+            <a:endParaRPr lang="en-US" sz="1100" dirty="0"/>
+          </a:p>
+        </p:txBody>
+      </p:sp>
+      <p:sp>
+        <p:nvSpPr>
+          <p:cNvPr id="12" name="Text 8"/>
+          <p:cNvSpPr txBox="1"/>
+          <p:nvPr/>
+        </p:nvSpPr>
+        <p:spPr>
+          <a:xfrm>
+            <a:off x="9500616" y="4315968"/>
+            <a:ext cx="2121408" cy="685800"/>
+          </a:xfrm>
+          <a:prstGeom prst="rect">
+            <a:avLst/>
+          </a:prstGeom>
+          <a:noFill/>
+          <a:ln/>
+        </p:spPr>
+        <p:txBody>
+          <a:bodyPr wrap="square" rtlCol="0" anchor="t"/>
+          <a:lstStyle/>
+          <a:p>
+            <a:pPr indent="0" marL="0">
+              <a:buNone/>
+            </a:pPr>
+            <a:r>
+              <a:rPr lang="en-US" sz="3200" b="1" dirty="0">
+                <a:solidFill>
+                  <a:srgbClr val="33291F"/>
+                </a:solidFill>
+                <a:latin typeface="Cambria" pitchFamily="34" charset="0"/>
+                <a:ea typeface="Cambria" pitchFamily="34" charset="-122"/>
+                <a:cs typeface="Cambria" pitchFamily="34" charset="-120"/>
+              </a:rPr>
+              <a:t>266</a:t>
+            </a:r>
+            <a:endParaRPr lang="en-US" sz="3200" dirty="0"/>
+          </a:p>
+        </p:txBody>
+      </p:sp>
+      <p:sp>
+        <p:nvSpPr>
+          <p:cNvPr id="13" name="Text 9"/>
+          <p:cNvSpPr txBox="1"/>
+          <p:nvPr/>
+        </p:nvSpPr>
+        <p:spPr>
+          <a:xfrm>
+            <a:off x="9500616" y="4974336"/>
+            <a:ext cx="2121408" cy="548640"/>
+          </a:xfrm>
+          <a:prstGeom prst="rect">
+            <a:avLst/>
+          </a:prstGeom>
+          <a:noFill/>
+          <a:ln/>
+        </p:spPr>
+        <p:txBody>
+          <a:bodyPr wrap="square" rtlCol="0" anchor="ctr"/>
+          <a:lstStyle/>
+          <a:p>
+            <a:pPr indent="0" marL="0">
+              <a:buNone/>
+            </a:pPr>
+            <a:r>
+              <a:rPr lang="en-US" sz="1100" spc="70" kern="0" dirty="0">
+                <a:solidFill>
+                  <a:srgbClr val="8A7A67"/>
+                </a:solidFill>
+                <a:latin typeface="Calibri" pitchFamily="34" charset="0"/>
+                <a:ea typeface="Calibri" pitchFamily="34" charset="-122"/>
+                <a:cs typeface="Calibri" pitchFamily="34" charset="-120"/>
+              </a:rPr>
+              <a:t>MIN DE TURNO</a:t>
+            </a:r>
+            <a:endParaRPr lang="en-US" sz="1100" dirty="0"/>
+          </a:p>
+        </p:txBody>
+      </p:sp>
+      <p:sp>
+        <p:nvSpPr>
+          <p:cNvPr id="14" name="Shape 10"/>
           <p:cNvSpPr/>
           <p:nvPr/>
         </p:nvSpPr>
         <p:spPr>
           <a:xfrm>
-            <a:off x="566928" y="3886200"/>
-            <a:ext cx="5344668" cy="1691640"/>
+            <a:off x="7379208" y="5394960"/>
+            <a:ext cx="4242816" cy="0"/>
+          </a:xfrm>
+          <a:prstGeom prst="line">
+            <a:avLst/>
+          </a:prstGeom>
+          <a:noFill/>
+          <a:ln w="12700">
+            <a:solidFill>
+              <a:srgbClr val="E6DCCB"/>
+            </a:solidFill>
+            <a:prstDash val="solid"/>
+          </a:ln>
+        </p:spPr>
+      </p:sp>
+      <p:sp>
+        <p:nvSpPr>
+          <p:cNvPr id="15" name="Text 11"/>
+          <p:cNvSpPr txBox="1"/>
+          <p:nvPr/>
+        </p:nvSpPr>
+        <p:spPr>
+          <a:xfrm>
+            <a:off x="7379208" y="5522976"/>
+            <a:ext cx="4242816" cy="1005840"/>
+          </a:xfrm>
+          <a:prstGeom prst="rect">
+            <a:avLst/>
+          </a:prstGeom>
+          <a:noFill/>
+          <a:ln/>
+        </p:spPr>
+        <p:txBody>
+          <a:bodyPr wrap="square" rtlCol="0" anchor="t"/>
+          <a:lstStyle/>
+          <a:p>
+            <a:pPr indent="0" marL="0">
+              <a:lnSpc>
+                <a:spcPct val="112000"/>
+              </a:lnSpc>
+              <a:buNone/>
+            </a:pPr>
+            <a:r>
+              <a:rPr lang="en-US" sz="1700" dirty="0">
+                <a:solidFill>
+                  <a:srgbClr val="33291F"/>
+                </a:solidFill>
+                <a:latin typeface="Cambria" pitchFamily="34" charset="0"/>
+                <a:ea typeface="Cambria" pitchFamily="34" charset="-122"/>
+                <a:cs typeface="Cambria" pitchFamily="34" charset="-120"/>
+              </a:rPr>
+              <a:t>Nesta ordem a urgência alta vem antes da baixa, que era exatamente o que faltava na rota anterior.</a:t>
+            </a:r>
+            <a:endParaRPr lang="en-US" sz="1700" dirty="0"/>
+          </a:p>
+        </p:txBody>
+      </p:sp>
+    </p:spTree>
+  </p:cSld>
+  <p:clrMapOvr>
+    <a:masterClrMapping/>
+  </p:clrMapOvr>
+</p:sld>
+</file>
+
+<file path=ppt/slides/slide19.xml><?xml version="1.0" encoding="utf-8"?>
+<p:sld xmlns:a="http://schemas.openxmlformats.org/drawingml/2006/main" xmlns:r="http://schemas.openxmlformats.org/officeDocument/2006/relationships" xmlns:p="http://schemas.openxmlformats.org/presentationml/2006/main">
+  <p:cSld name="Slide 19">
+    <p:bg>
+      <p:bgPr>
+        <a:blipFill dpi="0" rotWithShape="1">
+          <a:blip r:embed="rId1">
+            <a:lum/>
+          </a:blip>
+          <a:srcRect/>
+          <a:stretch>
+            <a:fillRect/>
+          </a:stretch>
+        </a:blipFill>
+        <a:effectLst/>
+      </p:bgPr>
+    </p:bg>
+    <p:spTree>
+      <p:nvGrpSpPr>
+        <p:cNvPr id="1" name=""/>
+        <p:cNvGrpSpPr/>
+        <p:nvPr/>
+      </p:nvGrpSpPr>
+      <p:grpSpPr>
+        <a:xfrm>
+          <a:off x="0" y="0"/>
+          <a:ext cx="0" cy="0"/>
+          <a:chOff x="0" y="0"/>
+          <a:chExt cx="0" cy="0"/>
+        </a:xfrm>
+      </p:grpSpPr>
+      <p:sp>
+        <p:nvSpPr>
+          <p:cNvPr id="3" name="Text 0"/>
+          <p:cNvSpPr txBox="1"/>
+          <p:nvPr/>
+        </p:nvSpPr>
+        <p:spPr>
+          <a:xfrm>
+            <a:off x="566928" y="347472"/>
+            <a:ext cx="11055096" cy="292608"/>
+          </a:xfrm>
+          <a:prstGeom prst="rect">
+            <a:avLst/>
+          </a:prstGeom>
+          <a:noFill/>
+          <a:ln/>
+        </p:spPr>
+        <p:txBody>
+          <a:bodyPr wrap="square" rtlCol="0" anchor="ctr"/>
+          <a:lstStyle/>
+          <a:p>
+            <a:pPr indent="0" marL="0">
+              <a:buNone/>
+            </a:pPr>
+            <a:r>
+              <a:rPr lang="en-US" sz="1300" b="1" spc="160" kern="0" dirty="0">
+                <a:solidFill>
+                  <a:srgbClr val="B35C38"/>
+                </a:solidFill>
+                <a:latin typeface="Calibri" pitchFamily="34" charset="0"/>
+                <a:ea typeface="Calibri" pitchFamily="34" charset="-122"/>
+                <a:cs typeface="Calibri" pitchFamily="34" charset="-120"/>
+              </a:rPr>
+              <a:t>DEMONSTRAÇÃO · RESULTADO</a:t>
+            </a:r>
+            <a:endParaRPr lang="en-US" sz="1300" dirty="0"/>
+          </a:p>
+        </p:txBody>
+      </p:sp>
+      <p:sp>
+        <p:nvSpPr>
+          <p:cNvPr id="4" name="Text 1"/>
+          <p:cNvSpPr txBox="1"/>
+          <p:nvPr/>
+        </p:nvSpPr>
+        <p:spPr>
+          <a:xfrm>
+            <a:off x="566928" y="658368"/>
+            <a:ext cx="11055096" cy="731520"/>
+          </a:xfrm>
+          <a:prstGeom prst="rect">
+            <a:avLst/>
+          </a:prstGeom>
+          <a:noFill/>
+          <a:ln/>
+        </p:spPr>
+        <p:txBody>
+          <a:bodyPr wrap="square" rtlCol="0" anchor="t"/>
+          <a:lstStyle/>
+          <a:p>
+            <a:pPr indent="0" marL="0">
+              <a:lnSpc>
+                <a:spcPct val="100000"/>
+              </a:lnSpc>
+              <a:buNone/>
+            </a:pPr>
+            <a:r>
+              <a:rPr lang="en-US" sz="3400" b="1" dirty="0">
+                <a:solidFill>
+                  <a:srgbClr val="33291F"/>
+                </a:solidFill>
+                <a:latin typeface="Cambria" pitchFamily="34" charset="0"/>
+                <a:ea typeface="Cambria" pitchFamily="34" charset="-122"/>
+                <a:cs typeface="Cambria" pitchFamily="34" charset="-120"/>
+              </a:rPr>
+              <a:t>O protocolo formalizado sobre a rota</a:t>
+            </a:r>
+            <a:endParaRPr lang="en-US" sz="3400" dirty="0"/>
+          </a:p>
+        </p:txBody>
+      </p:sp>
+      <p:sp>
+        <p:nvSpPr>
+          <p:cNvPr id="5" name="Shape 2"/>
+          <p:cNvSpPr/>
+          <p:nvPr/>
+        </p:nvSpPr>
+        <p:spPr>
+          <a:xfrm>
+            <a:off x="512064" y="1517904"/>
+            <a:ext cx="6510528" cy="4773168"/>
           </a:xfrm>
           <a:prstGeom prst="roundRect">
             <a:avLst>
-              <a:gd name="adj" fmla="val 7027"/>
+              <a:gd name="adj" fmla="val 1916"/>
             </a:avLst>
           </a:prstGeom>
           <a:solidFill>
@@ -4851,106 +7482,421 @@
           </a:ln>
         </p:spPr>
       </p:sp>
-      <p:sp>
-        <p:nvSpPr>
-          <p:cNvPr id="8" name="Text 5"/>
-          <p:cNvSpPr txBox="1"/>
-          <p:nvPr/>
-        </p:nvSpPr>
-        <p:spPr>
-          <a:xfrm>
-            <a:off x="822960" y="4078224"/>
-            <a:ext cx="4832604" cy="256032"/>
-          </a:xfrm>
-          <a:prstGeom prst="rect">
-            <a:avLst/>
-          </a:prstGeom>
-          <a:noFill/>
-          <a:ln/>
-        </p:spPr>
-        <p:txBody>
-          <a:bodyPr wrap="square" rtlCol="0" anchor="ctr"/>
-          <a:lstStyle/>
-          <a:p>
-            <a:pPr indent="0" marL="0">
-              <a:buNone/>
-            </a:pPr>
-            <a:r>
-              <a:rPr lang="en-US" sz="1200" b="1" spc="120" kern="0" dirty="0">
-                <a:solidFill>
-                  <a:srgbClr val="B35C38"/>
-                </a:solidFill>
-                <a:latin typeface="Calibri" pitchFamily="34" charset="0"/>
-                <a:ea typeface="Calibri" pitchFamily="34" charset="-122"/>
-                <a:cs typeface="Calibri" pitchFamily="34" charset="-120"/>
-              </a:rPr>
-              <a:t>TIRE A CAMADA DECLARATIVA</a:t>
-            </a:r>
-            <a:endParaRPr lang="en-US" sz="1200" dirty="0"/>
-          </a:p>
-        </p:txBody>
-      </p:sp>
-      <p:sp>
-        <p:nvSpPr>
-          <p:cNvPr id="9" name="Text 6"/>
-          <p:cNvSpPr txBox="1"/>
-          <p:nvPr/>
-        </p:nvSpPr>
-        <p:spPr>
-          <a:xfrm>
-            <a:off x="822960" y="4443984"/>
-            <a:ext cx="4832604" cy="1005840"/>
-          </a:xfrm>
-          <a:prstGeom prst="rect">
-            <a:avLst/>
-          </a:prstGeom>
-          <a:noFill/>
-          <a:ln/>
-        </p:spPr>
-        <p:txBody>
-          <a:bodyPr wrap="square" rtlCol="0" anchor="t"/>
-          <a:lstStyle/>
-          <a:p>
-            <a:pPr indent="0" marL="0">
-              <a:lnSpc>
-                <a:spcPct val="112000"/>
-              </a:lnSpc>
-              <a:buNone/>
-            </a:pPr>
-            <a:r>
-              <a:rPr lang="en-US" sz="2000" dirty="0">
-                <a:solidFill>
-                  <a:srgbClr val="5C4F41"/>
-                </a:solidFill>
-                <a:latin typeface="Calibri" pitchFamily="34" charset="0"/>
-                <a:ea typeface="Calibri" pitchFamily="34" charset="-122"/>
-                <a:cs typeface="Calibri" pitchFamily="34" charset="-120"/>
-              </a:rPr>
-              <a:t>O programa procedural volta a falhar assim que entra uma regra que ninguém previu ao escrevê-lo.</a:t>
-            </a:r>
-            <a:endParaRPr lang="en-US" sz="2000" dirty="0"/>
-          </a:p>
-        </p:txBody>
-      </p:sp>
-      <p:sp>
-        <p:nvSpPr>
-          <p:cNvPr id="10" name="Shape 7"/>
+      <p:pic>
+        <p:nvPicPr>
+          <p:cNvPr id="6" name="Image 0" descr="apresentacao\3\passos\passo6.jpg">    </p:cNvPr>
+          <p:cNvPicPr>
+            <a:picLocks noChangeAspect="1"/>
+          </p:cNvPicPr>
+          <p:nvPr/>
+        </p:nvPicPr>
+        <p:blipFill>
+          <a:blip r:embed="rId2"/>
+          <a:stretch>
+            <a:fillRect/>
+          </a:stretch>
+        </p:blipFill>
+        <p:spPr>
+          <a:xfrm>
+            <a:off x="566928" y="1572768"/>
+            <a:ext cx="6400800" cy="4663440"/>
+          </a:xfrm>
+          <a:prstGeom prst="rect">
+            <a:avLst/>
+          </a:prstGeom>
+        </p:spPr>
+      </p:pic>
+      <p:sp>
+        <p:nvSpPr>
+          <p:cNvPr id="7" name="Shape 3"/>
           <p:cNvSpPr/>
           <p:nvPr/>
         </p:nvSpPr>
         <p:spPr>
           <a:xfrm>
-            <a:off x="6277356" y="3886200"/>
-            <a:ext cx="5344668" cy="1691640"/>
+            <a:off x="7379208" y="1691640"/>
+            <a:ext cx="3200400" cy="384048"/>
           </a:xfrm>
           <a:prstGeom prst="roundRect">
             <a:avLst>
-              <a:gd name="adj" fmla="val 7027"/>
+              <a:gd name="adj" fmla="val 119048"/>
             </a:avLst>
           </a:prstGeom>
           <a:solidFill>
-            <a:srgbClr val="FFFDF8"/>
+            <a:srgbClr val="DDE7E0"/>
           </a:solidFill>
+          <a:ln w="12700">
+            <a:solidFill>
+              <a:srgbClr val="DDE7E0"/>
+            </a:solidFill>
+            <a:prstDash val="solid"/>
+          </a:ln>
+        </p:spPr>
+      </p:sp>
+      <p:sp>
+        <p:nvSpPr>
+          <p:cNvPr id="8" name="Text 4"/>
+          <p:cNvSpPr txBox="1"/>
+          <p:nvPr/>
+        </p:nvSpPr>
+        <p:spPr>
+          <a:xfrm>
+            <a:off x="7379208" y="1691640"/>
+            <a:ext cx="3200400" cy="384048"/>
+          </a:xfrm>
+          <a:prstGeom prst="rect">
+            <a:avLst/>
+          </a:prstGeom>
+          <a:noFill/>
+          <a:ln/>
+        </p:spPr>
+        <p:txBody>
+          <a:bodyPr wrap="square" rtlCol="0" anchor="ctr"/>
+          <a:lstStyle/>
+          <a:p>
+            <a:pPr algn="ctr" indent="0" marL="0">
+              <a:buNone/>
+            </a:pPr>
+            <a:r>
+              <a:rPr lang="en-US" sz="1300" b="1" dirty="0">
+                <a:solidFill>
+                  <a:srgbClr val="4A6B5B"/>
+                </a:solidFill>
+                <a:latin typeface="Calibri" pitchFamily="34" charset="0"/>
+                <a:ea typeface="Calibri" pitchFamily="34" charset="-122"/>
+                <a:cs typeface="Calibri" pitchFamily="34" charset="-120"/>
+              </a:rPr>
+              <a:t>rota válida sob o protocolo</a:t>
+            </a:r>
+            <a:endParaRPr lang="en-US" sz="1300" dirty="0"/>
+          </a:p>
+        </p:txBody>
+      </p:sp>
+      <p:sp>
+        <p:nvSpPr>
+          <p:cNvPr id="9" name="Text 5"/>
+          <p:cNvSpPr txBox="1"/>
+          <p:nvPr/>
+        </p:nvSpPr>
+        <p:spPr>
+          <a:xfrm>
+            <a:off x="7379208" y="2258568"/>
+            <a:ext cx="4242816" cy="2286000"/>
+          </a:xfrm>
+          <a:prstGeom prst="rect">
+            <a:avLst/>
+          </a:prstGeom>
+          <a:noFill/>
+          <a:ln/>
+        </p:spPr>
+        <p:txBody>
+          <a:bodyPr wrap="square" rtlCol="0" anchor="t"/>
+          <a:lstStyle/>
+          <a:p>
+            <a:pPr indent="0" marL="0">
+              <a:lnSpc>
+                <a:spcPct val="114000"/>
+              </a:lnSpc>
+              <a:buNone/>
+            </a:pPr>
+            <a:r>
+              <a:rPr lang="en-US" sz="1700" dirty="0">
+                <a:solidFill>
+                  <a:srgbClr val="5C4F41"/>
+                </a:solidFill>
+                <a:latin typeface="Calibri" pitchFamily="34" charset="0"/>
+                <a:ea typeface="Calibri" pitchFamily="34" charset="-122"/>
+                <a:cs typeface="Calibri" pitchFamily="34" charset="-120"/>
+              </a:rPr>
+              <a:t>A saída não é uma linha no mapa, é um </a:t>
+            </a:r>
+            <a:pPr indent="0" marL="0">
+              <a:lnSpc>
+                <a:spcPct val="114000"/>
+              </a:lnSpc>
+              <a:buNone/>
+            </a:pPr>
+            <a:r>
+              <a:rPr lang="en-US" sz="1700" b="1" dirty="0">
+                <a:solidFill>
+                  <a:srgbClr val="5C4F41"/>
+                </a:solidFill>
+                <a:latin typeface="Calibri" pitchFamily="34" charset="0"/>
+                <a:ea typeface="Calibri" pitchFamily="34" charset="-122"/>
+                <a:cs typeface="Calibri" pitchFamily="34" charset="-120"/>
+              </a:rPr>
+              <a:t>roteiro</a:t>
+            </a:r>
+            <a:pPr indent="0" marL="0">
+              <a:lnSpc>
+                <a:spcPct val="114000"/>
+              </a:lnSpc>
+              <a:buNone/>
+            </a:pPr>
+            <a:r>
+              <a:rPr lang="en-US" sz="1700" dirty="0">
+                <a:solidFill>
+                  <a:srgbClr val="5C4F41"/>
+                </a:solidFill>
+                <a:latin typeface="Calibri" pitchFamily="34" charset="0"/>
+                <a:ea typeface="Calibri" pitchFamily="34" charset="-122"/>
+                <a:cs typeface="Calibri" pitchFamily="34" charset="-120"/>
+              </a:rPr>
+              <a:t>: em cada parada, o que fazer, em que ordem, e quando sair da rota para repor material na unidade. Neste turno o plano decidiu um desvio de reposição, em tracejado.</a:t>
+            </a:r>
+            <a:endParaRPr lang="en-US" sz="1700" dirty="0"/>
+          </a:p>
+        </p:txBody>
+      </p:sp>
+      <p:sp>
+        <p:nvSpPr>
+          <p:cNvPr id="10" name="Text 6"/>
+          <p:cNvSpPr txBox="1"/>
+          <p:nvPr/>
+        </p:nvSpPr>
+        <p:spPr>
+          <a:xfrm>
+            <a:off x="7379208" y="4315968"/>
+            <a:ext cx="1414272" cy="685800"/>
+          </a:xfrm>
+          <a:prstGeom prst="rect">
+            <a:avLst/>
+          </a:prstGeom>
+          <a:noFill/>
+          <a:ln/>
+        </p:spPr>
+        <p:txBody>
+          <a:bodyPr wrap="square" rtlCol="0" anchor="t"/>
+          <a:lstStyle/>
+          <a:p>
+            <a:pPr indent="0" marL="0">
+              <a:buNone/>
+            </a:pPr>
+            <a:r>
+              <a:rPr lang="en-US" sz="3200" b="1" dirty="0">
+                <a:solidFill>
+                  <a:srgbClr val="33291F"/>
+                </a:solidFill>
+                <a:latin typeface="Cambria" pitchFamily="34" charset="0"/>
+                <a:ea typeface="Cambria" pitchFamily="34" charset="-122"/>
+                <a:cs typeface="Cambria" pitchFamily="34" charset="-120"/>
+              </a:rPr>
+              <a:t>6</a:t>
+            </a:r>
+            <a:endParaRPr lang="en-US" sz="3200" dirty="0"/>
+          </a:p>
+        </p:txBody>
+      </p:sp>
+      <p:sp>
+        <p:nvSpPr>
+          <p:cNvPr id="11" name="Text 7"/>
+          <p:cNvSpPr txBox="1"/>
+          <p:nvPr/>
+        </p:nvSpPr>
+        <p:spPr>
+          <a:xfrm>
+            <a:off x="7379208" y="4974336"/>
+            <a:ext cx="1414272" cy="548640"/>
+          </a:xfrm>
+          <a:prstGeom prst="rect">
+            <a:avLst/>
+          </a:prstGeom>
+          <a:noFill/>
+          <a:ln/>
+        </p:spPr>
+        <p:txBody>
+          <a:bodyPr wrap="square" rtlCol="0" anchor="ctr"/>
+          <a:lstStyle/>
+          <a:p>
+            <a:pPr indent="0" marL="0">
+              <a:buNone/>
+            </a:pPr>
+            <a:r>
+              <a:rPr lang="en-US" sz="1100" spc="70" kern="0" dirty="0">
+                <a:solidFill>
+                  <a:srgbClr val="8A7A67"/>
+                </a:solidFill>
+                <a:latin typeface="Calibri" pitchFamily="34" charset="0"/>
+                <a:ea typeface="Calibri" pitchFamily="34" charset="-122"/>
+                <a:cs typeface="Calibri" pitchFamily="34" charset="-120"/>
+              </a:rPr>
+              <a:t>VISITAS</a:t>
+            </a:r>
+            <a:endParaRPr lang="en-US" sz="1100" dirty="0"/>
+          </a:p>
+        </p:txBody>
+      </p:sp>
+      <p:sp>
+        <p:nvSpPr>
+          <p:cNvPr id="12" name="Text 8"/>
+          <p:cNvSpPr txBox="1"/>
+          <p:nvPr/>
+        </p:nvSpPr>
+        <p:spPr>
+          <a:xfrm>
+            <a:off x="8793480" y="4315968"/>
+            <a:ext cx="1414272" cy="685800"/>
+          </a:xfrm>
+          <a:prstGeom prst="rect">
+            <a:avLst/>
+          </a:prstGeom>
+          <a:noFill/>
+          <a:ln/>
+        </p:spPr>
+        <p:txBody>
+          <a:bodyPr wrap="square" rtlCol="0" anchor="t"/>
+          <a:lstStyle/>
+          <a:p>
+            <a:pPr indent="0" marL="0">
+              <a:buNone/>
+            </a:pPr>
+            <a:r>
+              <a:rPr lang="en-US" sz="3200" b="1" dirty="0">
+                <a:solidFill>
+                  <a:srgbClr val="33291F"/>
+                </a:solidFill>
+                <a:latin typeface="Cambria" pitchFamily="34" charset="0"/>
+                <a:ea typeface="Cambria" pitchFamily="34" charset="-122"/>
+                <a:cs typeface="Cambria" pitchFamily="34" charset="-120"/>
+              </a:rPr>
+              <a:t>266</a:t>
+            </a:r>
+            <a:endParaRPr lang="en-US" sz="3200" dirty="0"/>
+          </a:p>
+        </p:txBody>
+      </p:sp>
+      <p:sp>
+        <p:nvSpPr>
+          <p:cNvPr id="13" name="Text 9"/>
+          <p:cNvSpPr txBox="1"/>
+          <p:nvPr/>
+        </p:nvSpPr>
+        <p:spPr>
+          <a:xfrm>
+            <a:off x="8793480" y="4974336"/>
+            <a:ext cx="1414272" cy="548640"/>
+          </a:xfrm>
+          <a:prstGeom prst="rect">
+            <a:avLst/>
+          </a:prstGeom>
+          <a:noFill/>
+          <a:ln/>
+        </p:spPr>
+        <p:txBody>
+          <a:bodyPr wrap="square" rtlCol="0" anchor="ctr"/>
+          <a:lstStyle/>
+          <a:p>
+            <a:pPr indent="0" marL="0">
+              <a:buNone/>
+            </a:pPr>
+            <a:r>
+              <a:rPr lang="en-US" sz="1100" spc="70" kern="0" dirty="0">
+                <a:solidFill>
+                  <a:srgbClr val="8A7A67"/>
+                </a:solidFill>
+                <a:latin typeface="Calibri" pitchFamily="34" charset="0"/>
+                <a:ea typeface="Calibri" pitchFamily="34" charset="-122"/>
+                <a:cs typeface="Calibri" pitchFamily="34" charset="-120"/>
+              </a:rPr>
+              <a:t>MIN DE TURNO</a:t>
+            </a:r>
+            <a:endParaRPr lang="en-US" sz="1100" dirty="0"/>
+          </a:p>
+        </p:txBody>
+      </p:sp>
+      <p:sp>
+        <p:nvSpPr>
+          <p:cNvPr id="14" name="Text 10"/>
+          <p:cNvSpPr txBox="1"/>
+          <p:nvPr/>
+        </p:nvSpPr>
+        <p:spPr>
+          <a:xfrm>
+            <a:off x="10207752" y="4315968"/>
+            <a:ext cx="1414272" cy="685800"/>
+          </a:xfrm>
+          <a:prstGeom prst="rect">
+            <a:avLst/>
+          </a:prstGeom>
+          <a:noFill/>
+          <a:ln/>
+        </p:spPr>
+        <p:txBody>
+          <a:bodyPr wrap="square" rtlCol="0" anchor="t"/>
+          <a:lstStyle/>
+          <a:p>
+            <a:pPr indent="0" marL="0">
+              <a:buNone/>
+            </a:pPr>
+            <a:r>
+              <a:rPr lang="en-US" sz="3200" b="1" dirty="0">
+                <a:solidFill>
+                  <a:srgbClr val="33291F"/>
+                </a:solidFill>
+                <a:latin typeface="Cambria" pitchFamily="34" charset="0"/>
+                <a:ea typeface="Cambria" pitchFamily="34" charset="-122"/>
+                <a:cs typeface="Cambria" pitchFamily="34" charset="-120"/>
+              </a:rPr>
+              <a:t>51</a:t>
+            </a:r>
+            <a:endParaRPr lang="en-US" sz="3200" dirty="0"/>
+          </a:p>
+        </p:txBody>
+      </p:sp>
+      <p:sp>
+        <p:nvSpPr>
+          <p:cNvPr id="15" name="Text 11"/>
+          <p:cNvSpPr txBox="1"/>
+          <p:nvPr/>
+        </p:nvSpPr>
+        <p:spPr>
+          <a:xfrm>
+            <a:off x="10207752" y="4974336"/>
+            <a:ext cx="1414272" cy="548640"/>
+          </a:xfrm>
+          <a:prstGeom prst="rect">
+            <a:avLst/>
+          </a:prstGeom>
+          <a:noFill/>
+          <a:ln/>
+        </p:spPr>
+        <p:txBody>
+          <a:bodyPr wrap="square" rtlCol="0" anchor="ctr"/>
+          <a:lstStyle/>
+          <a:p>
+            <a:pPr indent="0" marL="0">
+              <a:buNone/>
+            </a:pPr>
+            <a:r>
+              <a:rPr lang="en-US" sz="1100" spc="70" kern="0" dirty="0">
+                <a:solidFill>
+                  <a:srgbClr val="8A7A67"/>
+                </a:solidFill>
+                <a:latin typeface="Calibri" pitchFamily="34" charset="0"/>
+                <a:ea typeface="Calibri" pitchFamily="34" charset="-122"/>
+                <a:cs typeface="Calibri" pitchFamily="34" charset="-120"/>
+              </a:rPr>
+              <a:t>AÇÕES</a:t>
+            </a:r>
+            <a:endParaRPr lang="en-US" sz="1100" dirty="0"/>
+          </a:p>
+        </p:txBody>
+      </p:sp>
+      <p:sp>
+        <p:nvSpPr>
+          <p:cNvPr id="16" name="Shape 12"/>
+          <p:cNvSpPr/>
+          <p:nvPr/>
+        </p:nvSpPr>
+        <p:spPr>
+          <a:xfrm>
+            <a:off x="7379208" y="5394960"/>
+            <a:ext cx="4242816" cy="0"/>
+          </a:xfrm>
+          <a:prstGeom prst="line">
+            <a:avLst/>
+          </a:prstGeom>
+          <a:noFill/>
           <a:ln w="12700">
             <a:solidFill>
               <a:srgbClr val="E6DCCB"/>
@@ -4961,53 +7907,14 @@
       </p:sp>
       <p:sp>
         <p:nvSpPr>
-          <p:cNvPr id="11" name="Text 8"/>
-          <p:cNvSpPr txBox="1"/>
-          <p:nvPr/>
-        </p:nvSpPr>
-        <p:spPr>
-          <a:xfrm>
-            <a:off x="6533388" y="4078224"/>
-            <a:ext cx="4832604" cy="256032"/>
-          </a:xfrm>
-          <a:prstGeom prst="rect">
-            <a:avLst/>
-          </a:prstGeom>
-          <a:noFill/>
-          <a:ln/>
-        </p:spPr>
-        <p:txBody>
-          <a:bodyPr wrap="square" rtlCol="0" anchor="ctr"/>
-          <a:lstStyle/>
-          <a:p>
-            <a:pPr indent="0" marL="0">
-              <a:buNone/>
-            </a:pPr>
-            <a:r>
-              <a:rPr lang="en-US" sz="1200" b="1" spc="120" kern="0" dirty="0">
-                <a:solidFill>
-                  <a:srgbClr val="B35C38"/>
-                </a:solidFill>
-                <a:latin typeface="Calibri" pitchFamily="34" charset="0"/>
-                <a:ea typeface="Calibri" pitchFamily="34" charset="-122"/>
-                <a:cs typeface="Calibri" pitchFamily="34" charset="-120"/>
-              </a:rPr>
-              <a:t>TIRE A BUSCA HEURÍSTICA</a:t>
-            </a:r>
-            <a:endParaRPr lang="en-US" sz="1200" dirty="0"/>
-          </a:p>
-        </p:txBody>
-      </p:sp>
-      <p:sp>
-        <p:nvSpPr>
-          <p:cNvPr id="12" name="Text 9"/>
-          <p:cNvSpPr txBox="1"/>
-          <p:nvPr/>
-        </p:nvSpPr>
-        <p:spPr>
-          <a:xfrm>
-            <a:off x="6533388" y="4443984"/>
-            <a:ext cx="4832604" cy="1005840"/>
+          <p:cNvPr id="17" name="Text 13"/>
+          <p:cNvSpPr txBox="1"/>
+          <p:nvPr/>
+        </p:nvSpPr>
+        <p:spPr>
+          <a:xfrm>
+            <a:off x="7379208" y="5522976"/>
+            <a:ext cx="4242816" cy="1005840"/>
           </a:xfrm>
           <a:prstGeom prst="rect">
             <a:avLst/>
@@ -5026,49 +7933,7 @@
               <a:buNone/>
             </a:pPr>
             <a:r>
-              <a:rPr lang="en-US" sz="2000" dirty="0">
-                <a:solidFill>
-                  <a:srgbClr val="5C4F41"/>
-                </a:solidFill>
-                <a:latin typeface="Calibri" pitchFamily="34" charset="0"/>
-                <a:ea typeface="Calibri" pitchFamily="34" charset="-122"/>
-                <a:cs typeface="Calibri" pitchFamily="34" charset="-120"/>
-              </a:rPr>
-              <a:t>Varrer o mesmo modelo sem heurística para em 5 ou 6 pacientes, e um turno real tem de 10 a 15.</a:t>
-            </a:r>
-            <a:endParaRPr lang="en-US" sz="2000" dirty="0"/>
-          </a:p>
-        </p:txBody>
-      </p:sp>
-      <p:sp>
-        <p:nvSpPr>
-          <p:cNvPr id="13" name="Text 10"/>
-          <p:cNvSpPr txBox="1"/>
-          <p:nvPr/>
-        </p:nvSpPr>
-        <p:spPr>
-          <a:xfrm>
-            <a:off x="566928" y="5806440"/>
-            <a:ext cx="11055096" cy="868680"/>
-          </a:xfrm>
-          <a:prstGeom prst="rect">
-            <a:avLst/>
-          </a:prstGeom>
-          <a:noFill/>
-          <a:ln/>
-        </p:spPr>
-        <p:txBody>
-          <a:bodyPr wrap="square" rtlCol="0" anchor="t"/>
-          <a:lstStyle/>
-          <a:p>
-            <a:pPr indent="0" marL="0">
-              <a:lnSpc>
-                <a:spcPct val="110000"/>
-              </a:lnSpc>
-              <a:buNone/>
-            </a:pPr>
-            <a:r>
-              <a:rPr lang="en-US" sz="2100" dirty="0">
+              <a:rPr lang="en-US" sz="1700" dirty="0">
                 <a:solidFill>
                   <a:srgbClr val="33291F"/>
                 </a:solidFill>
@@ -5076,43 +7941,9 @@
                 <a:ea typeface="Cambria" pitchFamily="34" charset="-122"/>
                 <a:cs typeface="Cambria" pitchFamily="34" charset="-120"/>
               </a:rPr>
-              <a:t>O trunfo do trabalho não é ter usado Planning. É termos medido </a:t>
-            </a:r>
-            <a:pPr indent="0" marL="0">
-              <a:lnSpc>
-                <a:spcPct val="110000"/>
-              </a:lnSpc>
-              <a:buNone/>
-            </a:pPr>
-            <a:r>
-              <a:rPr lang="en-US" sz="2100" b="1" dirty="0">
-                <a:solidFill>
-                  <a:srgbClr val="33291F"/>
-                </a:solidFill>
-                <a:latin typeface="Cambria" pitchFamily="34" charset="0"/>
-                <a:ea typeface="Cambria" pitchFamily="34" charset="-122"/>
-                <a:cs typeface="Cambria" pitchFamily="34" charset="-120"/>
-              </a:rPr>
-              <a:t>como</a:t>
-            </a:r>
-            <a:pPr indent="0" marL="0">
-              <a:lnSpc>
-                <a:spcPct val="110000"/>
-              </a:lnSpc>
-              <a:buNone/>
-            </a:pPr>
-            <a:r>
-              <a:rPr lang="en-US" sz="2100" dirty="0">
-                <a:solidFill>
-                  <a:srgbClr val="33291F"/>
-                </a:solidFill>
-                <a:latin typeface="Cambria" pitchFamily="34" charset="0"/>
-                <a:ea typeface="Cambria" pitchFamily="34" charset="-122"/>
-                <a:cs typeface="Cambria" pitchFamily="34" charset="-120"/>
-              </a:rPr>
-              <a:t> ele ajuda, inclusive descobrindo que a resposta não era a que esperávamos.</a:t>
-            </a:r>
-            <a:endParaRPr lang="en-US" sz="2100" dirty="0"/>
+              <a:t>Trocar o roteirizador não muda uma linha do domínio. Mudar a lei não muda uma linha do código de busca.</a:t>
+            </a:r>
+            <a:endParaRPr lang="en-US" sz="1700" dirty="0"/>
           </a:p>
         </p:txBody>
       </p:sp>
@@ -5573,6 +8404,487 @@
                 <a:cs typeface="Cambria" pitchFamily="34" charset="-120"/>
               </a:rPr>
               <a:t>A pergunta não é qual o menor percurso, e sim se aquela sequência de atendimentos é executável sem violar a norma.</a:t>
+            </a:r>
+            <a:endParaRPr lang="en-US" sz="2100" dirty="0"/>
+          </a:p>
+        </p:txBody>
+      </p:sp>
+    </p:spTree>
+  </p:cSld>
+  <p:clrMapOvr>
+    <a:masterClrMapping/>
+  </p:clrMapOvr>
+</p:sld>
+</file>
+
+<file path=ppt/slides/slide20.xml><?xml version="1.0" encoding="utf-8"?>
+<p:sld xmlns:a="http://schemas.openxmlformats.org/drawingml/2006/main" xmlns:r="http://schemas.openxmlformats.org/officeDocument/2006/relationships" xmlns:p="http://schemas.openxmlformats.org/presentationml/2006/main">
+  <p:cSld name="Slide 20">
+    <p:bg>
+      <p:bgPr>
+        <a:blipFill dpi="0" rotWithShape="1">
+          <a:blip r:embed="rId1">
+            <a:lum/>
+          </a:blip>
+          <a:srcRect/>
+          <a:stretch>
+            <a:fillRect/>
+          </a:stretch>
+        </a:blipFill>
+        <a:effectLst/>
+      </p:bgPr>
+    </p:bg>
+    <p:spTree>
+      <p:nvGrpSpPr>
+        <p:cNvPr id="1" name=""/>
+        <p:cNvGrpSpPr/>
+        <p:nvPr/>
+      </p:nvGrpSpPr>
+      <p:grpSpPr>
+        <a:xfrm>
+          <a:off x="0" y="0"/>
+          <a:ext cx="0" cy="0"/>
+          <a:chOff x="0" y="0"/>
+          <a:chExt cx="0" cy="0"/>
+        </a:xfrm>
+      </p:grpSpPr>
+      <p:sp>
+        <p:nvSpPr>
+          <p:cNvPr id="3" name="Text 0"/>
+          <p:cNvSpPr txBox="1"/>
+          <p:nvPr/>
+        </p:nvSpPr>
+        <p:spPr>
+          <a:xfrm>
+            <a:off x="566928" y="347472"/>
+            <a:ext cx="11055096" cy="292608"/>
+          </a:xfrm>
+          <a:prstGeom prst="rect">
+            <a:avLst/>
+          </a:prstGeom>
+          <a:noFill/>
+          <a:ln/>
+        </p:spPr>
+        <p:txBody>
+          <a:bodyPr wrap="square" rtlCol="0" anchor="ctr"/>
+          <a:lstStyle/>
+          <a:p>
+            <a:pPr indent="0" marL="0">
+              <a:buNone/>
+            </a:pPr>
+            <a:r>
+              <a:rPr lang="en-US" sz="1300" b="1" spc="160" kern="0" dirty="0">
+                <a:solidFill>
+                  <a:srgbClr val="B35C38"/>
+                </a:solidFill>
+                <a:latin typeface="Calibri" pitchFamily="34" charset="0"/>
+                <a:ea typeface="Calibri" pitchFamily="34" charset="-122"/>
+                <a:cs typeface="Calibri" pitchFamily="34" charset="-120"/>
+              </a:rPr>
+              <a:t>CONCLUSÃO</a:t>
+            </a:r>
+            <a:endParaRPr lang="en-US" sz="1300" dirty="0"/>
+          </a:p>
+        </p:txBody>
+      </p:sp>
+      <p:sp>
+        <p:nvSpPr>
+          <p:cNvPr id="4" name="Text 1"/>
+          <p:cNvSpPr txBox="1"/>
+          <p:nvPr/>
+        </p:nvSpPr>
+        <p:spPr>
+          <a:xfrm>
+            <a:off x="566928" y="676656"/>
+            <a:ext cx="11055096" cy="914400"/>
+          </a:xfrm>
+          <a:prstGeom prst="rect">
+            <a:avLst/>
+          </a:prstGeom>
+          <a:noFill/>
+          <a:ln/>
+        </p:spPr>
+        <p:txBody>
+          <a:bodyPr wrap="square" rtlCol="0" anchor="t"/>
+          <a:lstStyle/>
+          <a:p>
+            <a:pPr indent="0" marL="0">
+              <a:lnSpc>
+                <a:spcPct val="100000"/>
+              </a:lnSpc>
+              <a:buNone/>
+            </a:pPr>
+            <a:r>
+              <a:rPr lang="en-US" sz="4000" b="1" dirty="0">
+                <a:solidFill>
+                  <a:srgbClr val="33291F"/>
+                </a:solidFill>
+                <a:latin typeface="Cambria" pitchFamily="34" charset="0"/>
+                <a:ea typeface="Cambria" pitchFamily="34" charset="-122"/>
+                <a:cs typeface="Cambria" pitchFamily="34" charset="-120"/>
+              </a:rPr>
+              <a:t>A hipótese que sobreviveu aos experimentos</a:t>
+            </a:r>
+            <a:endParaRPr lang="en-US" sz="4000" dirty="0"/>
+          </a:p>
+        </p:txBody>
+      </p:sp>
+      <p:sp>
+        <p:nvSpPr>
+          <p:cNvPr id="5" name="Shape 2"/>
+          <p:cNvSpPr/>
+          <p:nvPr/>
+        </p:nvSpPr>
+        <p:spPr>
+          <a:xfrm>
+            <a:off x="566928" y="1783080"/>
+            <a:ext cx="11055096" cy="1828800"/>
+          </a:xfrm>
+          <a:prstGeom prst="roundRect">
+            <a:avLst>
+              <a:gd name="adj" fmla="val 7000"/>
+            </a:avLst>
+          </a:prstGeom>
+          <a:solidFill>
+            <a:srgbClr val="DDE7E0"/>
+          </a:solidFill>
+          <a:ln w="12700">
+            <a:solidFill>
+              <a:srgbClr val="DDE7E0"/>
+            </a:solidFill>
+            <a:prstDash val="solid"/>
+          </a:ln>
+        </p:spPr>
+      </p:sp>
+      <p:sp>
+        <p:nvSpPr>
+          <p:cNvPr id="6" name="Text 3"/>
+          <p:cNvSpPr txBox="1"/>
+          <p:nvPr/>
+        </p:nvSpPr>
+        <p:spPr>
+          <a:xfrm>
+            <a:off x="877824" y="2011680"/>
+            <a:ext cx="10433304" cy="1417320"/>
+          </a:xfrm>
+          <a:prstGeom prst="rect">
+            <a:avLst/>
+          </a:prstGeom>
+          <a:noFill/>
+          <a:ln/>
+        </p:spPr>
+        <p:txBody>
+          <a:bodyPr wrap="square" rtlCol="0" anchor="t"/>
+          <a:lstStyle/>
+          <a:p>
+            <a:pPr indent="0" marL="0">
+              <a:lnSpc>
+                <a:spcPct val="112000"/>
+              </a:lnSpc>
+              <a:buNone/>
+            </a:pPr>
+            <a:r>
+              <a:rPr lang="en-US" sz="2500" i="1" dirty="0">
+                <a:solidFill>
+                  <a:srgbClr val="33291F"/>
+                </a:solidFill>
+                <a:latin typeface="Cambria" pitchFamily="34" charset="0"/>
+                <a:ea typeface="Cambria" pitchFamily="34" charset="-122"/>
+                <a:cs typeface="Cambria" pitchFamily="34" charset="-120"/>
+              </a:rPr>
+              <a:t>“Manter a norma como especificação declarativa preserva a corretude do sistema diante de regras novas, a um custo de busca que ainda cabe num turno real.”</a:t>
+            </a:r>
+            <a:endParaRPr lang="en-US" sz="2500" dirty="0"/>
+          </a:p>
+        </p:txBody>
+      </p:sp>
+      <p:sp>
+        <p:nvSpPr>
+          <p:cNvPr id="7" name="Shape 4"/>
+          <p:cNvSpPr/>
+          <p:nvPr/>
+        </p:nvSpPr>
+        <p:spPr>
+          <a:xfrm>
+            <a:off x="566928" y="3886200"/>
+            <a:ext cx="5344668" cy="1691640"/>
+          </a:xfrm>
+          <a:prstGeom prst="roundRect">
+            <a:avLst>
+              <a:gd name="adj" fmla="val 7027"/>
+            </a:avLst>
+          </a:prstGeom>
+          <a:solidFill>
+            <a:srgbClr val="FFFDF8"/>
+          </a:solidFill>
+          <a:ln w="12700">
+            <a:solidFill>
+              <a:srgbClr val="E6DCCB"/>
+            </a:solidFill>
+            <a:prstDash val="solid"/>
+          </a:ln>
+        </p:spPr>
+      </p:sp>
+      <p:sp>
+        <p:nvSpPr>
+          <p:cNvPr id="8" name="Text 5"/>
+          <p:cNvSpPr txBox="1"/>
+          <p:nvPr/>
+        </p:nvSpPr>
+        <p:spPr>
+          <a:xfrm>
+            <a:off x="822960" y="4078224"/>
+            <a:ext cx="4832604" cy="256032"/>
+          </a:xfrm>
+          <a:prstGeom prst="rect">
+            <a:avLst/>
+          </a:prstGeom>
+          <a:noFill/>
+          <a:ln/>
+        </p:spPr>
+        <p:txBody>
+          <a:bodyPr wrap="square" rtlCol="0" anchor="ctr"/>
+          <a:lstStyle/>
+          <a:p>
+            <a:pPr indent="0" marL="0">
+              <a:buNone/>
+            </a:pPr>
+            <a:r>
+              <a:rPr lang="en-US" sz="1200" b="1" spc="120" kern="0" dirty="0">
+                <a:solidFill>
+                  <a:srgbClr val="B35C38"/>
+                </a:solidFill>
+                <a:latin typeface="Calibri" pitchFamily="34" charset="0"/>
+                <a:ea typeface="Calibri" pitchFamily="34" charset="-122"/>
+                <a:cs typeface="Calibri" pitchFamily="34" charset="-120"/>
+              </a:rPr>
+              <a:t>TIRE A CAMADA DECLARATIVA</a:t>
+            </a:r>
+            <a:endParaRPr lang="en-US" sz="1200" dirty="0"/>
+          </a:p>
+        </p:txBody>
+      </p:sp>
+      <p:sp>
+        <p:nvSpPr>
+          <p:cNvPr id="9" name="Text 6"/>
+          <p:cNvSpPr txBox="1"/>
+          <p:nvPr/>
+        </p:nvSpPr>
+        <p:spPr>
+          <a:xfrm>
+            <a:off x="822960" y="4443984"/>
+            <a:ext cx="4832604" cy="1005840"/>
+          </a:xfrm>
+          <a:prstGeom prst="rect">
+            <a:avLst/>
+          </a:prstGeom>
+          <a:noFill/>
+          <a:ln/>
+        </p:spPr>
+        <p:txBody>
+          <a:bodyPr wrap="square" rtlCol="0" anchor="t"/>
+          <a:lstStyle/>
+          <a:p>
+            <a:pPr indent="0" marL="0">
+              <a:lnSpc>
+                <a:spcPct val="112000"/>
+              </a:lnSpc>
+              <a:buNone/>
+            </a:pPr>
+            <a:r>
+              <a:rPr lang="en-US" sz="2000" dirty="0">
+                <a:solidFill>
+                  <a:srgbClr val="5C4F41"/>
+                </a:solidFill>
+                <a:latin typeface="Calibri" pitchFamily="34" charset="0"/>
+                <a:ea typeface="Calibri" pitchFamily="34" charset="-122"/>
+                <a:cs typeface="Calibri" pitchFamily="34" charset="-120"/>
+              </a:rPr>
+              <a:t>O programa procedural volta a falhar assim que entra uma regra que ninguém previu ao escrevê-lo.</a:t>
+            </a:r>
+            <a:endParaRPr lang="en-US" sz="2000" dirty="0"/>
+          </a:p>
+        </p:txBody>
+      </p:sp>
+      <p:sp>
+        <p:nvSpPr>
+          <p:cNvPr id="10" name="Shape 7"/>
+          <p:cNvSpPr/>
+          <p:nvPr/>
+        </p:nvSpPr>
+        <p:spPr>
+          <a:xfrm>
+            <a:off x="6277356" y="3886200"/>
+            <a:ext cx="5344668" cy="1691640"/>
+          </a:xfrm>
+          <a:prstGeom prst="roundRect">
+            <a:avLst>
+              <a:gd name="adj" fmla="val 7027"/>
+            </a:avLst>
+          </a:prstGeom>
+          <a:solidFill>
+            <a:srgbClr val="FFFDF8"/>
+          </a:solidFill>
+          <a:ln w="12700">
+            <a:solidFill>
+              <a:srgbClr val="E6DCCB"/>
+            </a:solidFill>
+            <a:prstDash val="solid"/>
+          </a:ln>
+        </p:spPr>
+      </p:sp>
+      <p:sp>
+        <p:nvSpPr>
+          <p:cNvPr id="11" name="Text 8"/>
+          <p:cNvSpPr txBox="1"/>
+          <p:nvPr/>
+        </p:nvSpPr>
+        <p:spPr>
+          <a:xfrm>
+            <a:off x="6533388" y="4078224"/>
+            <a:ext cx="4832604" cy="256032"/>
+          </a:xfrm>
+          <a:prstGeom prst="rect">
+            <a:avLst/>
+          </a:prstGeom>
+          <a:noFill/>
+          <a:ln/>
+        </p:spPr>
+        <p:txBody>
+          <a:bodyPr wrap="square" rtlCol="0" anchor="ctr"/>
+          <a:lstStyle/>
+          <a:p>
+            <a:pPr indent="0" marL="0">
+              <a:buNone/>
+            </a:pPr>
+            <a:r>
+              <a:rPr lang="en-US" sz="1200" b="1" spc="120" kern="0" dirty="0">
+                <a:solidFill>
+                  <a:srgbClr val="B35C38"/>
+                </a:solidFill>
+                <a:latin typeface="Calibri" pitchFamily="34" charset="0"/>
+                <a:ea typeface="Calibri" pitchFamily="34" charset="-122"/>
+                <a:cs typeface="Calibri" pitchFamily="34" charset="-120"/>
+              </a:rPr>
+              <a:t>TIRE A BUSCA HEURÍSTICA</a:t>
+            </a:r>
+            <a:endParaRPr lang="en-US" sz="1200" dirty="0"/>
+          </a:p>
+        </p:txBody>
+      </p:sp>
+      <p:sp>
+        <p:nvSpPr>
+          <p:cNvPr id="12" name="Text 9"/>
+          <p:cNvSpPr txBox="1"/>
+          <p:nvPr/>
+        </p:nvSpPr>
+        <p:spPr>
+          <a:xfrm>
+            <a:off x="6533388" y="4443984"/>
+            <a:ext cx="4832604" cy="1005840"/>
+          </a:xfrm>
+          <a:prstGeom prst="rect">
+            <a:avLst/>
+          </a:prstGeom>
+          <a:noFill/>
+          <a:ln/>
+        </p:spPr>
+        <p:txBody>
+          <a:bodyPr wrap="square" rtlCol="0" anchor="t"/>
+          <a:lstStyle/>
+          <a:p>
+            <a:pPr indent="0" marL="0">
+              <a:lnSpc>
+                <a:spcPct val="112000"/>
+              </a:lnSpc>
+              <a:buNone/>
+            </a:pPr>
+            <a:r>
+              <a:rPr lang="en-US" sz="2000" dirty="0">
+                <a:solidFill>
+                  <a:srgbClr val="5C4F41"/>
+                </a:solidFill>
+                <a:latin typeface="Calibri" pitchFamily="34" charset="0"/>
+                <a:ea typeface="Calibri" pitchFamily="34" charset="-122"/>
+                <a:cs typeface="Calibri" pitchFamily="34" charset="-120"/>
+              </a:rPr>
+              <a:t>Varrer o mesmo modelo sem heurística para em 5 ou 6 pacientes, e um turno real tem de 10 a 15.</a:t>
+            </a:r>
+            <a:endParaRPr lang="en-US" sz="2000" dirty="0"/>
+          </a:p>
+        </p:txBody>
+      </p:sp>
+      <p:sp>
+        <p:nvSpPr>
+          <p:cNvPr id="13" name="Text 10"/>
+          <p:cNvSpPr txBox="1"/>
+          <p:nvPr/>
+        </p:nvSpPr>
+        <p:spPr>
+          <a:xfrm>
+            <a:off x="566928" y="5806440"/>
+            <a:ext cx="11055096" cy="868680"/>
+          </a:xfrm>
+          <a:prstGeom prst="rect">
+            <a:avLst/>
+          </a:prstGeom>
+          <a:noFill/>
+          <a:ln/>
+        </p:spPr>
+        <p:txBody>
+          <a:bodyPr wrap="square" rtlCol="0" anchor="t"/>
+          <a:lstStyle/>
+          <a:p>
+            <a:pPr indent="0" marL="0">
+              <a:lnSpc>
+                <a:spcPct val="110000"/>
+              </a:lnSpc>
+              <a:buNone/>
+            </a:pPr>
+            <a:r>
+              <a:rPr lang="en-US" sz="2100" dirty="0">
+                <a:solidFill>
+                  <a:srgbClr val="33291F"/>
+                </a:solidFill>
+                <a:latin typeface="Cambria" pitchFamily="34" charset="0"/>
+                <a:ea typeface="Cambria" pitchFamily="34" charset="-122"/>
+                <a:cs typeface="Cambria" pitchFamily="34" charset="-120"/>
+              </a:rPr>
+              <a:t>O trunfo do trabalho não é ter usado Planning. É termos medido </a:t>
+            </a:r>
+            <a:pPr indent="0" marL="0">
+              <a:lnSpc>
+                <a:spcPct val="110000"/>
+              </a:lnSpc>
+              <a:buNone/>
+            </a:pPr>
+            <a:r>
+              <a:rPr lang="en-US" sz="2100" b="1" dirty="0">
+                <a:solidFill>
+                  <a:srgbClr val="33291F"/>
+                </a:solidFill>
+                <a:latin typeface="Cambria" pitchFamily="34" charset="0"/>
+                <a:ea typeface="Cambria" pitchFamily="34" charset="-122"/>
+                <a:cs typeface="Cambria" pitchFamily="34" charset="-120"/>
+              </a:rPr>
+              <a:t>como</a:t>
+            </a:r>
+            <a:pPr indent="0" marL="0">
+              <a:lnSpc>
+                <a:spcPct val="110000"/>
+              </a:lnSpc>
+              <a:buNone/>
+            </a:pPr>
+            <a:r>
+              <a:rPr lang="en-US" sz="2100" dirty="0">
+                <a:solidFill>
+                  <a:srgbClr val="33291F"/>
+                </a:solidFill>
+                <a:latin typeface="Cambria" pitchFamily="34" charset="0"/>
+                <a:ea typeface="Cambria" pitchFamily="34" charset="-122"/>
+                <a:cs typeface="Cambria" pitchFamily="34" charset="-120"/>
+              </a:rPr>
+              <a:t> ele ajuda, inclusive descobrindo que a resposta não era a que esperávamos.</a:t>
             </a:r>
             <a:endParaRPr lang="en-US" sz="2100" dirty="0"/>
           </a:p>

</xml_diff>